<commit_message>
player retention curve fix
</commit_message>
<xml_diff>
--- a/Delivery 1 KPIs/Deliverables/To Deliver/Game_Analytics_Presentation.pptx
+++ b/Delivery 1 KPIs/Deliverables/To Deliver/Game_Analytics_Presentation.pptx
@@ -264,7 +264,7 @@
           <a:p>
             <a:fld id="{5BCAD085-E8A6-8845-BD4E-CB4CCA059FC4}" type="datetimeFigureOut">
               <a:rPr lang="en-US" smtClean="0"/>
-              <a:t>11/5/25</a:t>
+              <a:t>11/7/25</a:t>
             </a:fld>
             <a:endParaRPr lang="en-US"/>
           </a:p>
@@ -434,7 +434,7 @@
           <a:p>
             <a:fld id="{5BCAD085-E8A6-8845-BD4E-CB4CCA059FC4}" type="datetimeFigureOut">
               <a:rPr lang="en-US" smtClean="0"/>
-              <a:t>11/5/25</a:t>
+              <a:t>11/7/25</a:t>
             </a:fld>
             <a:endParaRPr lang="en-US"/>
           </a:p>
@@ -614,7 +614,7 @@
           <a:p>
             <a:fld id="{5BCAD085-E8A6-8845-BD4E-CB4CCA059FC4}" type="datetimeFigureOut">
               <a:rPr lang="en-US" smtClean="0"/>
-              <a:t>11/5/25</a:t>
+              <a:t>11/7/25</a:t>
             </a:fld>
             <a:endParaRPr lang="en-US"/>
           </a:p>
@@ -784,7 +784,7 @@
           <a:p>
             <a:fld id="{5BCAD085-E8A6-8845-BD4E-CB4CCA059FC4}" type="datetimeFigureOut">
               <a:rPr lang="en-US" smtClean="0"/>
-              <a:t>11/5/25</a:t>
+              <a:t>11/7/25</a:t>
             </a:fld>
             <a:endParaRPr lang="en-US"/>
           </a:p>
@@ -1028,7 +1028,7 @@
           <a:p>
             <a:fld id="{5BCAD085-E8A6-8845-BD4E-CB4CCA059FC4}" type="datetimeFigureOut">
               <a:rPr lang="en-US" smtClean="0"/>
-              <a:t>11/5/25</a:t>
+              <a:t>11/7/25</a:t>
             </a:fld>
             <a:endParaRPr lang="en-US"/>
           </a:p>
@@ -1260,7 +1260,7 @@
           <a:p>
             <a:fld id="{5BCAD085-E8A6-8845-BD4E-CB4CCA059FC4}" type="datetimeFigureOut">
               <a:rPr lang="en-US" smtClean="0"/>
-              <a:t>11/5/25</a:t>
+              <a:t>11/7/25</a:t>
             </a:fld>
             <a:endParaRPr lang="en-US"/>
           </a:p>
@@ -1627,7 +1627,7 @@
           <a:p>
             <a:fld id="{5BCAD085-E8A6-8845-BD4E-CB4CCA059FC4}" type="datetimeFigureOut">
               <a:rPr lang="en-US" smtClean="0"/>
-              <a:t>11/5/25</a:t>
+              <a:t>11/7/25</a:t>
             </a:fld>
             <a:endParaRPr lang="en-US"/>
           </a:p>
@@ -1745,7 +1745,7 @@
           <a:p>
             <a:fld id="{5BCAD085-E8A6-8845-BD4E-CB4CCA059FC4}" type="datetimeFigureOut">
               <a:rPr lang="en-US" smtClean="0"/>
-              <a:t>11/5/25</a:t>
+              <a:t>11/7/25</a:t>
             </a:fld>
             <a:endParaRPr lang="en-US"/>
           </a:p>
@@ -1840,7 +1840,7 @@
           <a:p>
             <a:fld id="{5BCAD085-E8A6-8845-BD4E-CB4CCA059FC4}" type="datetimeFigureOut">
               <a:rPr lang="en-US" smtClean="0"/>
-              <a:t>11/5/25</a:t>
+              <a:t>11/7/25</a:t>
             </a:fld>
             <a:endParaRPr lang="en-US"/>
           </a:p>
@@ -2117,7 +2117,7 @@
           <a:p>
             <a:fld id="{5BCAD085-E8A6-8845-BD4E-CB4CCA059FC4}" type="datetimeFigureOut">
               <a:rPr lang="en-US" smtClean="0"/>
-              <a:t>11/5/25</a:t>
+              <a:t>11/7/25</a:t>
             </a:fld>
             <a:endParaRPr lang="en-US"/>
           </a:p>
@@ -2374,7 +2374,7 @@
           <a:p>
             <a:fld id="{5BCAD085-E8A6-8845-BD4E-CB4CCA059FC4}" type="datetimeFigureOut">
               <a:rPr lang="en-US" smtClean="0"/>
-              <a:t>11/5/25</a:t>
+              <a:t>11/7/25</a:t>
             </a:fld>
             <a:endParaRPr lang="en-US"/>
           </a:p>
@@ -2587,7 +2587,7 @@
           <a:p>
             <a:fld id="{5BCAD085-E8A6-8845-BD4E-CB4CCA059FC4}" type="datetimeFigureOut">
               <a:rPr lang="en-US" smtClean="0"/>
-              <a:t>11/5/25</a:t>
+              <a:t>11/7/25</a:t>
             </a:fld>
             <a:endParaRPr lang="en-US"/>
           </a:p>
@@ -7602,6 +7602,36 @@
           <a:chExt cx="0" cy="0"/>
         </a:xfrm>
       </p:grpSpPr>
+      <p:pic>
+        <p:nvPicPr>
+          <p:cNvPr id="11" name="Picture 10" descr="A graph with a red line&#10;&#10;AI-generated content may be incorrect.">
+            <a:extLst>
+              <a:ext uri="{FF2B5EF4-FFF2-40B4-BE49-F238E27FC236}">
+                <a16:creationId xmlns:a16="http://schemas.microsoft.com/office/drawing/2014/main" id="{A8CDDB9C-D6FE-A8B4-588F-5C64ACCF51FE}"/>
+              </a:ext>
+            </a:extLst>
+          </p:cNvPr>
+          <p:cNvPicPr>
+            <a:picLocks noChangeAspect="1"/>
+          </p:cNvPicPr>
+          <p:nvPr/>
+        </p:nvPicPr>
+        <p:blipFill>
+          <a:blip r:embed="rId2"/>
+          <a:stretch>
+            <a:fillRect/>
+          </a:stretch>
+        </p:blipFill>
+        <p:spPr>
+          <a:xfrm>
+            <a:off x="1417317" y="2176270"/>
+            <a:ext cx="6736083" cy="4041650"/>
+          </a:xfrm>
+          <a:prstGeom prst="rect">
+            <a:avLst/>
+          </a:prstGeom>
+        </p:spPr>
+      </p:pic>
       <p:sp>
         <p:nvSpPr>
           <p:cNvPr id="2" name="TextBox 1"/>
@@ -7652,8 +7682,8 @@
         </p:nvSpPr>
         <p:spPr>
           <a:xfrm>
-            <a:off x="1645918" y="1371600"/>
-            <a:ext cx="6400799" cy="731520"/>
+            <a:off x="1099457" y="1371600"/>
+            <a:ext cx="7315200" cy="731520"/>
           </a:xfrm>
           <a:prstGeom prst="roundRect">
             <a:avLst/>
@@ -7711,8 +7741,8 @@
         </p:nvSpPr>
         <p:spPr>
           <a:xfrm>
-            <a:off x="1645919" y="1463040"/>
-            <a:ext cx="6400799" cy="492443"/>
+            <a:off x="1099457" y="1491138"/>
+            <a:ext cx="7315200" cy="492443"/>
           </a:xfrm>
           <a:prstGeom prst="rect">
             <a:avLst/>
@@ -7739,36 +7769,21 @@
               </a:defRPr>
             </a:pPr>
             <a:r>
+              <a:rPr lang="en-US" dirty="0"/>
+              <a:t>10.2% </a:t>
+            </a:r>
+            <a:r>
               <a:rPr dirty="0"/>
-              <a:t>65.6% D7 Retention - 3-4x Industry Average</a:t>
-            </a:r>
-          </a:p>
-        </p:txBody>
-      </p:sp>
-      <p:pic>
-        <p:nvPicPr>
-          <p:cNvPr id="5" name="Picture 4" descr="03_retention_curve.png"/>
-          <p:cNvPicPr>
-            <a:picLocks noChangeAspect="1"/>
-          </p:cNvPicPr>
-          <p:nvPr/>
-        </p:nvPicPr>
-        <p:blipFill>
-          <a:blip r:embed="rId2"/>
-          <a:stretch>
-            <a:fillRect/>
-          </a:stretch>
-        </p:blipFill>
-        <p:spPr>
-          <a:xfrm>
-            <a:off x="1645918" y="2309634"/>
-            <a:ext cx="6400800" cy="3840480"/>
-          </a:xfrm>
-          <a:prstGeom prst="rect">
-            <a:avLst/>
-          </a:prstGeom>
-        </p:spPr>
-      </p:pic>
+              <a:t>D7 Retention</a:t>
+            </a:r>
+            <a:r>
+              <a:rPr lang="en-US" dirty="0"/>
+              <a:t> – Solid with Growing Potential</a:t>
+            </a:r>
+            <a:endParaRPr dirty="0"/>
+          </a:p>
+        </p:txBody>
+      </p:sp>
       <p:sp>
         <p:nvSpPr>
           <p:cNvPr id="6" name="TextBox 5"/>
@@ -7778,7 +7793,7 @@
         <p:spPr>
           <a:xfrm>
             <a:off x="914400" y="6217920"/>
-            <a:ext cx="7315200" cy="457200"/>
+            <a:ext cx="7315200" cy="338554"/>
           </a:xfrm>
           <a:prstGeom prst="rect">
             <a:avLst/>
@@ -7800,8 +7815,12 @@
               </a:defRPr>
             </a:pPr>
             <a:r>
+              <a:rPr lang="en-US" dirty="0"/>
+              <a:t>Solid </a:t>
+            </a:r>
+            <a:r>
               <a:rPr dirty="0"/>
-              <a:t>Exceptional product-market fit - users who try, stay</a:t>
+              <a:t>product-market fit - users who try, stay</a:t>
             </a:r>
           </a:p>
         </p:txBody>

</xml_diff>

<commit_message>
csv for Delivery 2 generated, + some example csv
</commit_message>
<xml_diff>
--- a/Delivery 1 KPIs/Deliverables/To Deliver/Game_Analytics_Presentation.pptx
+++ b/Delivery 1 KPIs/Deliverables/To Deliver/Game_Analytics_Presentation.pptx
@@ -10,12 +10,14 @@
     <p:sldId id="258" r:id="rId4"/>
     <p:sldId id="259" r:id="rId5"/>
     <p:sldId id="260" r:id="rId6"/>
-    <p:sldId id="261" r:id="rId7"/>
-    <p:sldId id="262" r:id="rId8"/>
-    <p:sldId id="263" r:id="rId9"/>
-    <p:sldId id="264" r:id="rId10"/>
-    <p:sldId id="265" r:id="rId11"/>
-    <p:sldId id="267" r:id="rId12"/>
+    <p:sldId id="268" r:id="rId7"/>
+    <p:sldId id="261" r:id="rId8"/>
+    <p:sldId id="262" r:id="rId9"/>
+    <p:sldId id="269" r:id="rId10"/>
+    <p:sldId id="263" r:id="rId11"/>
+    <p:sldId id="264" r:id="rId12"/>
+    <p:sldId id="265" r:id="rId13"/>
+    <p:sldId id="267" r:id="rId14"/>
   </p:sldIdLst>
   <p:sldSz cx="9144000" cy="6858000" type="screen4x3"/>
   <p:notesSz cx="6858000" cy="9144000"/>
@@ -3101,42 +3103,6 @@
           </a:p>
         </p:txBody>
       </p:sp>
-      <p:sp>
-        <p:nvSpPr>
-          <p:cNvPr id="5" name="TextBox 4"/>
-          <p:cNvSpPr txBox="1"/>
-          <p:nvPr/>
-        </p:nvSpPr>
-        <p:spPr>
-          <a:xfrm>
-            <a:off x="914400" y="5029200"/>
-            <a:ext cx="7315200" cy="365760"/>
-          </a:xfrm>
-          <a:prstGeom prst="rect">
-            <a:avLst/>
-          </a:prstGeom>
-          <a:noFill/>
-        </p:spPr>
-        <p:txBody>
-          <a:bodyPr wrap="none">
-            <a:spAutoFit/>
-          </a:bodyPr>
-          <a:lstStyle/>
-          <a:p>
-            <a:pPr algn="ctr">
-              <a:defRPr sz="1800">
-                <a:solidFill>
-                  <a:srgbClr val="7F8C8D"/>
-                </a:solidFill>
-                <a:latin typeface="Calibri"/>
-              </a:defRPr>
-            </a:pPr>
-            <a:r>
-              <a:t>KPIs Analysis</a:t>
-            </a:r>
-          </a:p>
-        </p:txBody>
-      </p:sp>
     </p:spTree>
   </p:cSld>
   <p:clrMapOvr>
@@ -3162,6 +3128,714 @@
           <a:chExt cx="0" cy="0"/>
         </a:xfrm>
       </p:grpSpPr>
+      <p:pic>
+        <p:nvPicPr>
+          <p:cNvPr id="10" name="Picture 9" descr="A chart with numbers and a number of people&#10;&#10;AI-generated content may be incorrect.">
+            <a:extLst>
+              <a:ext uri="{FF2B5EF4-FFF2-40B4-BE49-F238E27FC236}">
+                <a16:creationId xmlns:a16="http://schemas.microsoft.com/office/drawing/2014/main" id="{EAE6632C-2896-68F4-8C3C-BE8606710AEF}"/>
+              </a:ext>
+            </a:extLst>
+          </p:cNvPr>
+          <p:cNvPicPr>
+            <a:picLocks noChangeAspect="1"/>
+          </p:cNvPicPr>
+          <p:nvPr/>
+        </p:nvPicPr>
+        <p:blipFill>
+          <a:blip r:embed="rId2"/>
+          <a:stretch>
+            <a:fillRect/>
+          </a:stretch>
+        </p:blipFill>
+        <p:spPr>
+          <a:xfrm>
+            <a:off x="-1" y="1595437"/>
+            <a:ext cx="6315076" cy="5262564"/>
+          </a:xfrm>
+          <a:prstGeom prst="rect">
+            <a:avLst/>
+          </a:prstGeom>
+        </p:spPr>
+      </p:pic>
+      <p:sp>
+        <p:nvSpPr>
+          <p:cNvPr id="2" name="TextBox 1"/>
+          <p:cNvSpPr txBox="1"/>
+          <p:nvPr/>
+        </p:nvSpPr>
+        <p:spPr>
+          <a:xfrm>
+            <a:off x="457200" y="457200"/>
+            <a:ext cx="8229600" cy="914400"/>
+          </a:xfrm>
+          <a:prstGeom prst="rect">
+            <a:avLst/>
+          </a:prstGeom>
+          <a:noFill/>
+        </p:spPr>
+        <p:txBody>
+          <a:bodyPr wrap="square">
+            <a:spAutoFit/>
+          </a:bodyPr>
+          <a:lstStyle/>
+          <a:p>
+            <a:pPr algn="ctr">
+              <a:defRPr sz="4000" b="1">
+                <a:solidFill>
+                  <a:srgbClr val="2C3E50"/>
+                </a:solidFill>
+                <a:latin typeface="Calibri"/>
+              </a:defRPr>
+            </a:pPr>
+            <a:r>
+              <a:t>High-Value Demographics</a:t>
+            </a:r>
+          </a:p>
+        </p:txBody>
+      </p:sp>
+      <p:sp>
+        <p:nvSpPr>
+          <p:cNvPr id="4" name="Rounded Rectangle 3"/>
+          <p:cNvSpPr/>
+          <p:nvPr/>
+        </p:nvSpPr>
+        <p:spPr>
+          <a:xfrm>
+            <a:off x="6315075" y="1645920"/>
+            <a:ext cx="2554605" cy="3883343"/>
+          </a:xfrm>
+          <a:prstGeom prst="roundRect">
+            <a:avLst/>
+          </a:prstGeom>
+          <a:solidFill>
+            <a:srgbClr val="F8F9FA"/>
+          </a:solidFill>
+          <a:ln w="6350">
+            <a:gradFill>
+              <a:gsLst>
+                <a:gs pos="0">
+                  <a:schemeClr val="accent1">
+                    <a:lumMod val="5000"/>
+                    <a:lumOff val="95000"/>
+                  </a:schemeClr>
+                </a:gs>
+                <a:gs pos="74000">
+                  <a:schemeClr val="accent1">
+                    <a:lumMod val="45000"/>
+                    <a:lumOff val="55000"/>
+                  </a:schemeClr>
+                </a:gs>
+                <a:gs pos="83000">
+                  <a:schemeClr val="accent1">
+                    <a:lumMod val="45000"/>
+                    <a:lumOff val="55000"/>
+                  </a:schemeClr>
+                </a:gs>
+                <a:gs pos="100000">
+                  <a:schemeClr val="accent1">
+                    <a:lumMod val="30000"/>
+                    <a:lumOff val="70000"/>
+                  </a:schemeClr>
+                </a:gs>
+              </a:gsLst>
+              <a:lin ang="3600000" scaled="0"/>
+            </a:gradFill>
+          </a:ln>
+          <a:effectLst>
+            <a:glow rad="579646">
+              <a:schemeClr val="accent1">
+                <a:lumMod val="60000"/>
+                <a:lumOff val="40000"/>
+                <a:alpha val="5000"/>
+              </a:schemeClr>
+            </a:glow>
+            <a:outerShdw blurRad="387716" dist="38100" dir="2700000" algn="tl" rotWithShape="0">
+              <a:prstClr val="black">
+                <a:alpha val="4000"/>
+              </a:prstClr>
+            </a:outerShdw>
+          </a:effectLst>
+        </p:spPr>
+        <p:style>
+          <a:lnRef idx="1">
+            <a:schemeClr val="accent1"/>
+          </a:lnRef>
+          <a:fillRef idx="3">
+            <a:schemeClr val="accent1"/>
+          </a:fillRef>
+          <a:effectRef idx="2">
+            <a:schemeClr val="accent1"/>
+          </a:effectRef>
+          <a:fontRef idx="minor">
+            <a:schemeClr val="lt1"/>
+          </a:fontRef>
+        </p:style>
+        <p:txBody>
+          <a:bodyPr rtlCol="0" anchor="ctr"/>
+          <a:lstStyle/>
+          <a:p>
+            <a:pPr algn="ctr"/>
+            <a:endParaRPr/>
+          </a:p>
+        </p:txBody>
+      </p:sp>
+      <p:sp>
+        <p:nvSpPr>
+          <p:cNvPr id="5" name="TextBox 4"/>
+          <p:cNvSpPr txBox="1"/>
+          <p:nvPr/>
+        </p:nvSpPr>
+        <p:spPr>
+          <a:xfrm>
+            <a:off x="6500812" y="2069226"/>
+            <a:ext cx="2185988" cy="3036729"/>
+          </a:xfrm>
+          <a:prstGeom prst="rect">
+            <a:avLst/>
+          </a:prstGeom>
+          <a:noFill/>
+        </p:spPr>
+        <p:txBody>
+          <a:bodyPr wrap="square">
+            <a:spAutoFit/>
+          </a:bodyPr>
+          <a:lstStyle/>
+          <a:p>
+            <a:pPr>
+              <a:spcAft>
+                <a:spcPts val="800"/>
+              </a:spcAft>
+              <a:defRPr sz="1600" b="1">
+                <a:solidFill>
+                  <a:srgbClr val="3498DB"/>
+                </a:solidFill>
+                <a:latin typeface="Calibri"/>
+              </a:defRPr>
+            </a:pPr>
+            <a:r>
+              <a:rPr dirty="0"/>
+              <a:t>Top Markets:</a:t>
+            </a:r>
+          </a:p>
+          <a:p>
+            <a:pPr>
+              <a:spcAft>
+                <a:spcPts val="800"/>
+              </a:spcAft>
+              <a:defRPr sz="1500">
+                <a:solidFill>
+                  <a:srgbClr val="212121"/>
+                </a:solidFill>
+                <a:latin typeface="Calibri"/>
+              </a:defRPr>
+            </a:pPr>
+            <a:r>
+              <a:rPr dirty="0"/>
+              <a:t>• Suriname: $39.19 ARPU</a:t>
+            </a:r>
+          </a:p>
+          <a:p>
+            <a:pPr>
+              <a:spcAft>
+                <a:spcPts val="800"/>
+              </a:spcAft>
+              <a:defRPr sz="1500">
+                <a:solidFill>
+                  <a:srgbClr val="212121"/>
+                </a:solidFill>
+                <a:latin typeface="Calibri"/>
+              </a:defRPr>
+            </a:pPr>
+            <a:r>
+              <a:rPr dirty="0"/>
+              <a:t>• Ireland: $22.98 ARPU</a:t>
+            </a:r>
+          </a:p>
+          <a:p>
+            <a:pPr>
+              <a:spcAft>
+                <a:spcPts val="800"/>
+              </a:spcAft>
+              <a:defRPr sz="1500">
+                <a:solidFill>
+                  <a:srgbClr val="212121"/>
+                </a:solidFill>
+                <a:latin typeface="Calibri"/>
+              </a:defRPr>
+            </a:pPr>
+            <a:endParaRPr dirty="0"/>
+          </a:p>
+          <a:p>
+            <a:pPr>
+              <a:spcAft>
+                <a:spcPts val="800"/>
+              </a:spcAft>
+              <a:defRPr sz="1600" b="1">
+                <a:solidFill>
+                  <a:srgbClr val="3498DB"/>
+                </a:solidFill>
+                <a:latin typeface="Calibri"/>
+              </a:defRPr>
+            </a:pPr>
+            <a:r>
+              <a:rPr dirty="0"/>
+              <a:t>Best Age Group:</a:t>
+            </a:r>
+          </a:p>
+          <a:p>
+            <a:pPr>
+              <a:spcAft>
+                <a:spcPts val="800"/>
+              </a:spcAft>
+              <a:defRPr sz="1500">
+                <a:solidFill>
+                  <a:srgbClr val="212121"/>
+                </a:solidFill>
+                <a:latin typeface="Calibri"/>
+              </a:defRPr>
+            </a:pPr>
+            <a:r>
+              <a:rPr dirty="0"/>
+              <a:t>• 18-25: $13.38 ARPU</a:t>
+            </a:r>
+          </a:p>
+          <a:p>
+            <a:pPr>
+              <a:spcAft>
+                <a:spcPts val="800"/>
+              </a:spcAft>
+              <a:defRPr sz="1500">
+                <a:solidFill>
+                  <a:srgbClr val="212121"/>
+                </a:solidFill>
+                <a:latin typeface="Calibri"/>
+              </a:defRPr>
+            </a:pPr>
+            <a:endParaRPr dirty="0"/>
+          </a:p>
+          <a:p>
+            <a:pPr>
+              <a:spcAft>
+                <a:spcPts val="800"/>
+              </a:spcAft>
+              <a:defRPr sz="1600" b="1">
+                <a:solidFill>
+                  <a:srgbClr val="3498DB"/>
+                </a:solidFill>
+                <a:latin typeface="Calibri"/>
+              </a:defRPr>
+            </a:pPr>
+            <a:r>
+              <a:rPr dirty="0"/>
+              <a:t>High-Value Profile:</a:t>
+            </a:r>
+          </a:p>
+          <a:p>
+            <a:pPr>
+              <a:spcAft>
+                <a:spcPts val="800"/>
+              </a:spcAft>
+              <a:defRPr sz="1500">
+                <a:solidFill>
+                  <a:srgbClr val="212121"/>
+                </a:solidFill>
+                <a:latin typeface="Calibri"/>
+              </a:defRPr>
+            </a:pPr>
+            <a:r>
+              <a:rPr dirty="0"/>
+              <a:t>Ireland + 18-25 age</a:t>
+            </a:r>
+          </a:p>
+        </p:txBody>
+      </p:sp>
+      <p:sp>
+        <p:nvSpPr>
+          <p:cNvPr id="6" name="TextBox 5"/>
+          <p:cNvSpPr txBox="1"/>
+          <p:nvPr/>
+        </p:nvSpPr>
+        <p:spPr>
+          <a:xfrm>
+            <a:off x="8229600" y="6492240"/>
+            <a:ext cx="731520" cy="274320"/>
+          </a:xfrm>
+          <a:prstGeom prst="rect">
+            <a:avLst/>
+          </a:prstGeom>
+          <a:noFill/>
+        </p:spPr>
+        <p:txBody>
+          <a:bodyPr wrap="none">
+            <a:spAutoFit/>
+          </a:bodyPr>
+          <a:lstStyle/>
+          <a:p>
+            <a:pPr algn="r">
+              <a:defRPr sz="1000">
+                <a:solidFill>
+                  <a:srgbClr val="7F8C8D"/>
+                </a:solidFill>
+                <a:latin typeface="Calibri"/>
+              </a:defRPr>
+            </a:pPr>
+            <a:r>
+              <a:t>8/10</a:t>
+            </a:r>
+          </a:p>
+        </p:txBody>
+      </p:sp>
+    </p:spTree>
+  </p:cSld>
+  <p:clrMapOvr>
+    <a:masterClrMapping/>
+  </p:clrMapOvr>
+</p:sld>
+</file>
+
+<file path=ppt/slides/slide11.xml><?xml version="1.0" encoding="utf-8"?>
+<p:sld xmlns:a="http://schemas.openxmlformats.org/drawingml/2006/main" xmlns:r="http://schemas.openxmlformats.org/officeDocument/2006/relationships" xmlns:p="http://schemas.openxmlformats.org/presentationml/2006/main">
+  <p:cSld>
+    <p:spTree>
+      <p:nvGrpSpPr>
+        <p:cNvPr id="1" name=""/>
+        <p:cNvGrpSpPr/>
+        <p:nvPr/>
+      </p:nvGrpSpPr>
+      <p:grpSpPr>
+        <a:xfrm>
+          <a:off x="0" y="0"/>
+          <a:ext cx="0" cy="0"/>
+          <a:chOff x="0" y="0"/>
+          <a:chExt cx="0" cy="0"/>
+        </a:xfrm>
+      </p:grpSpPr>
+      <p:sp>
+        <p:nvSpPr>
+          <p:cNvPr id="2" name="TextBox 1"/>
+          <p:cNvSpPr txBox="1"/>
+          <p:nvPr/>
+        </p:nvSpPr>
+        <p:spPr>
+          <a:xfrm>
+            <a:off x="457200" y="457200"/>
+            <a:ext cx="8229600" cy="914400"/>
+          </a:xfrm>
+          <a:prstGeom prst="rect">
+            <a:avLst/>
+          </a:prstGeom>
+          <a:noFill/>
+        </p:spPr>
+        <p:txBody>
+          <a:bodyPr wrap="square">
+            <a:spAutoFit/>
+          </a:bodyPr>
+          <a:lstStyle/>
+          <a:p>
+            <a:pPr algn="ctr">
+              <a:defRPr sz="3600" b="1">
+                <a:solidFill>
+                  <a:srgbClr val="2C3E50"/>
+                </a:solidFill>
+                <a:latin typeface="Calibri"/>
+              </a:defRPr>
+            </a:pPr>
+            <a:r>
+              <a:rPr dirty="0"/>
+              <a:t>Key Findings &amp; Recommendations</a:t>
+            </a:r>
+          </a:p>
+        </p:txBody>
+      </p:sp>
+      <p:sp>
+        <p:nvSpPr>
+          <p:cNvPr id="3" name="TextBox 2"/>
+          <p:cNvSpPr txBox="1"/>
+          <p:nvPr/>
+        </p:nvSpPr>
+        <p:spPr>
+          <a:xfrm>
+            <a:off x="1097280" y="2011680"/>
+            <a:ext cx="6949440" cy="1938992"/>
+          </a:xfrm>
+          <a:prstGeom prst="rect">
+            <a:avLst/>
+          </a:prstGeom>
+          <a:noFill/>
+        </p:spPr>
+        <p:txBody>
+          <a:bodyPr wrap="square">
+            <a:spAutoFit/>
+          </a:bodyPr>
+          <a:lstStyle/>
+          <a:p>
+            <a:pPr>
+              <a:spcBef>
+                <a:spcPts val="800"/>
+              </a:spcBef>
+              <a:spcAft>
+                <a:spcPts val="800"/>
+              </a:spcAft>
+              <a:defRPr sz="2000">
+                <a:solidFill>
+                  <a:srgbClr val="212121"/>
+                </a:solidFill>
+                <a:latin typeface="Calibri"/>
+              </a:defRPr>
+            </a:pPr>
+            <a:r>
+              <a:rPr lang="en-US" dirty="0"/>
+              <a:t>10.2</a:t>
+            </a:r>
+            <a:r>
+              <a:rPr dirty="0"/>
+              <a:t>% </a:t>
+            </a:r>
+            <a:r>
+              <a:rPr lang="en-US" dirty="0"/>
+              <a:t>D7 </a:t>
+            </a:r>
+            <a:r>
+              <a:rPr dirty="0"/>
+              <a:t>retention → Protect core gameplay loop</a:t>
+            </a:r>
+          </a:p>
+          <a:p>
+            <a:pPr>
+              <a:spcBef>
+                <a:spcPts val="800"/>
+              </a:spcBef>
+              <a:spcAft>
+                <a:spcPts val="800"/>
+              </a:spcAft>
+              <a:defRPr sz="2000">
+                <a:solidFill>
+                  <a:srgbClr val="212121"/>
+                </a:solidFill>
+                <a:latin typeface="Calibri"/>
+              </a:defRPr>
+            </a:pPr>
+            <a:r>
+              <a:rPr dirty="0"/>
+              <a:t>51.5% conversion → Focus on ARPPU growth, not conversion</a:t>
+            </a:r>
+          </a:p>
+          <a:p>
+            <a:pPr>
+              <a:spcBef>
+                <a:spcPts val="800"/>
+              </a:spcBef>
+              <a:spcAft>
+                <a:spcPts val="800"/>
+              </a:spcAft>
+              <a:defRPr sz="2000">
+                <a:solidFill>
+                  <a:srgbClr val="212121"/>
+                </a:solidFill>
+                <a:latin typeface="Calibri"/>
+              </a:defRPr>
+            </a:pPr>
+            <a:r>
+              <a:rPr dirty="0"/>
+              <a:t>Diamond Pack dominance → Expand $50-$100 premium tier</a:t>
+            </a:r>
+          </a:p>
+          <a:p>
+            <a:pPr>
+              <a:spcBef>
+                <a:spcPts val="800"/>
+              </a:spcBef>
+              <a:spcAft>
+                <a:spcPts val="800"/>
+              </a:spcAft>
+              <a:defRPr sz="2000">
+                <a:solidFill>
+                  <a:srgbClr val="212121"/>
+                </a:solidFill>
+                <a:latin typeface="Calibri"/>
+              </a:defRPr>
+            </a:pPr>
+            <a:r>
+              <a:rPr dirty="0"/>
+              <a:t>Geographic winners → Target Ireland, Suriname, Brazil for UA</a:t>
+            </a:r>
+          </a:p>
+        </p:txBody>
+      </p:sp>
+      <p:sp>
+        <p:nvSpPr>
+          <p:cNvPr id="4" name="Rounded Rectangle 3"/>
+          <p:cNvSpPr/>
+          <p:nvPr/>
+        </p:nvSpPr>
+        <p:spPr>
+          <a:xfrm>
+            <a:off x="1306285" y="5212080"/>
+            <a:ext cx="6531429" cy="914400"/>
+          </a:xfrm>
+          <a:prstGeom prst="roundRect">
+            <a:avLst/>
+          </a:prstGeom>
+          <a:gradFill flip="none" rotWithShape="1">
+            <a:gsLst>
+              <a:gs pos="0">
+                <a:schemeClr val="accent4">
+                  <a:alpha val="40687"/>
+                  <a:lumMod val="73000"/>
+                </a:schemeClr>
+              </a:gs>
+              <a:gs pos="48000">
+                <a:schemeClr val="accent6">
+                  <a:lumMod val="97421"/>
+                  <a:lumOff val="2579"/>
+                  <a:alpha val="76000"/>
+                </a:schemeClr>
+              </a:gs>
+              <a:gs pos="100000">
+                <a:schemeClr val="accent4">
+                  <a:alpha val="67000"/>
+                  <a:lumMod val="90000"/>
+                </a:schemeClr>
+              </a:gs>
+            </a:gsLst>
+            <a:path path="circle">
+              <a:fillToRect l="100000" t="100000"/>
+            </a:path>
+            <a:tileRect r="-100000" b="-100000"/>
+          </a:gradFill>
+          <a:ln w="6350">
+            <a:noFill/>
+          </a:ln>
+          <a:effectLst>
+            <a:outerShdw blurRad="535990" sx="98000" sy="98000" algn="ctr" rotWithShape="0">
+              <a:prstClr val="black">
+                <a:alpha val="18347"/>
+              </a:prstClr>
+            </a:outerShdw>
+          </a:effectLst>
+        </p:spPr>
+        <p:style>
+          <a:lnRef idx="1">
+            <a:schemeClr val="accent1"/>
+          </a:lnRef>
+          <a:fillRef idx="3">
+            <a:schemeClr val="accent1"/>
+          </a:fillRef>
+          <a:effectRef idx="2">
+            <a:schemeClr val="accent1"/>
+          </a:effectRef>
+          <a:fontRef idx="minor">
+            <a:schemeClr val="lt1"/>
+          </a:fontRef>
+        </p:style>
+        <p:txBody>
+          <a:bodyPr rtlCol="0" anchor="ctr"/>
+          <a:lstStyle/>
+          <a:p>
+            <a:pPr algn="ctr"/>
+            <a:endParaRPr/>
+          </a:p>
+        </p:txBody>
+      </p:sp>
+      <p:sp>
+        <p:nvSpPr>
+          <p:cNvPr id="5" name="TextBox 4"/>
+          <p:cNvSpPr txBox="1"/>
+          <p:nvPr/>
+        </p:nvSpPr>
+        <p:spPr>
+          <a:xfrm>
+            <a:off x="1306286" y="5303520"/>
+            <a:ext cx="6400800" cy="548640"/>
+          </a:xfrm>
+          <a:prstGeom prst="rect">
+            <a:avLst/>
+          </a:prstGeom>
+          <a:noFill/>
+        </p:spPr>
+        <p:txBody>
+          <a:bodyPr wrap="square">
+            <a:spAutoFit/>
+          </a:bodyPr>
+          <a:lstStyle/>
+          <a:p>
+            <a:pPr algn="ctr">
+              <a:defRPr sz="2200" b="1">
+                <a:solidFill>
+                  <a:srgbClr val="FFFFFF"/>
+                </a:solidFill>
+                <a:latin typeface="Calibri"/>
+              </a:defRPr>
+            </a:pPr>
+            <a:r>
+              <a:rPr dirty="0"/>
+              <a:t>Action: Scale premium monetization for +31% revenue potential</a:t>
+            </a:r>
+          </a:p>
+        </p:txBody>
+      </p:sp>
+      <p:sp>
+        <p:nvSpPr>
+          <p:cNvPr id="6" name="TextBox 5"/>
+          <p:cNvSpPr txBox="1"/>
+          <p:nvPr/>
+        </p:nvSpPr>
+        <p:spPr>
+          <a:xfrm>
+            <a:off x="8229600" y="6492240"/>
+            <a:ext cx="731520" cy="274320"/>
+          </a:xfrm>
+          <a:prstGeom prst="rect">
+            <a:avLst/>
+          </a:prstGeom>
+          <a:noFill/>
+        </p:spPr>
+        <p:txBody>
+          <a:bodyPr wrap="none">
+            <a:spAutoFit/>
+          </a:bodyPr>
+          <a:lstStyle/>
+          <a:p>
+            <a:pPr algn="r">
+              <a:defRPr sz="1000">
+                <a:solidFill>
+                  <a:srgbClr val="7F8C8D"/>
+                </a:solidFill>
+                <a:latin typeface="Calibri"/>
+              </a:defRPr>
+            </a:pPr>
+            <a:r>
+              <a:t>9/10</a:t>
+            </a:r>
+          </a:p>
+        </p:txBody>
+      </p:sp>
+    </p:spTree>
+  </p:cSld>
+  <p:clrMapOvr>
+    <a:masterClrMapping/>
+  </p:clrMapOvr>
+</p:sld>
+</file>
+
+<file path=ppt/slides/slide12.xml><?xml version="1.0" encoding="utf-8"?>
+<p:sld xmlns:a="http://schemas.openxmlformats.org/drawingml/2006/main" xmlns:r="http://schemas.openxmlformats.org/officeDocument/2006/relationships" xmlns:p="http://schemas.openxmlformats.org/presentationml/2006/main">
+  <p:cSld>
+    <p:spTree>
+      <p:nvGrpSpPr>
+        <p:cNvPr id="1" name=""/>
+        <p:cNvGrpSpPr/>
+        <p:nvPr/>
+      </p:nvGrpSpPr>
+      <p:grpSpPr>
+        <a:xfrm>
+          <a:off x="0" y="0"/>
+          <a:ext cx="0" cy="0"/>
+          <a:chOff x="0" y="0"/>
+          <a:chExt cx="0" cy="0"/>
+        </a:xfrm>
+      </p:grpSpPr>
       <p:sp>
         <p:nvSpPr>
           <p:cNvPr id="2" name="TextBox 1"/>
@@ -3642,57 +4316,13 @@
       </p:sp>
       <p:sp>
         <p:nvSpPr>
-          <p:cNvPr id="13" name="TextBox 12"/>
-          <p:cNvSpPr txBox="1"/>
-          <p:nvPr/>
-        </p:nvSpPr>
-        <p:spPr>
-          <a:xfrm>
-            <a:off x="1331595" y="4728765"/>
-            <a:ext cx="2303964" cy="338554"/>
-          </a:xfrm>
-          <a:prstGeom prst="rect">
-            <a:avLst/>
-          </a:prstGeom>
-          <a:noFill/>
-        </p:spPr>
-        <p:txBody>
-          <a:bodyPr wrap="none">
-            <a:spAutoFit/>
-          </a:bodyPr>
-          <a:lstStyle/>
-          <a:p>
-            <a:pPr>
-              <a:defRPr sz="1600">
-                <a:solidFill>
-                  <a:srgbClr val="2ECC71"/>
-                </a:solidFill>
-                <a:latin typeface="Calibri"/>
-              </a:defRPr>
-            </a:pPr>
-            <a:r>
-              <a:rPr dirty="0">
-                <a:solidFill>
-                  <a:schemeClr val="tx1">
-                    <a:lumMod val="95000"/>
-                    <a:lumOff val="5000"/>
-                  </a:schemeClr>
-                </a:solidFill>
-              </a:rPr>
-              <a:t>Professional presentation</a:t>
-            </a:r>
-          </a:p>
-        </p:txBody>
-      </p:sp>
-      <p:sp>
-        <p:nvSpPr>
           <p:cNvPr id="14" name="TextBox 13"/>
           <p:cNvSpPr txBox="1"/>
           <p:nvPr/>
         </p:nvSpPr>
         <p:spPr>
           <a:xfrm>
-            <a:off x="1331595" y="5021373"/>
+            <a:off x="1331595" y="4796119"/>
             <a:ext cx="3398751" cy="338554"/>
           </a:xfrm>
           <a:prstGeom prst="rect">
@@ -4180,7 +4810,7 @@
 </p:sld>
 </file>
 
-<file path=ppt/slides/slide11.xml><?xml version="1.0" encoding="utf-8"?>
+<file path=ppt/slides/slide13.xml><?xml version="1.0" encoding="utf-8"?>
 <p:sld xmlns:a="http://schemas.openxmlformats.org/drawingml/2006/main" xmlns:r="http://schemas.openxmlformats.org/officeDocument/2006/relationships" xmlns:p="http://schemas.openxmlformats.org/presentationml/2006/main">
   <p:cSld>
     <p:spTree>
@@ -7590,6 +8220,678 @@
   <p:cSld>
     <p:spTree>
       <p:nvGrpSpPr>
+        <p:cNvPr id="1" name="">
+          <a:extLst>
+            <a:ext uri="{FF2B5EF4-FFF2-40B4-BE49-F238E27FC236}">
+              <a16:creationId xmlns:a16="http://schemas.microsoft.com/office/drawing/2014/main" id="{31C37568-B407-5DAE-A469-18970CFB0A8F}"/>
+            </a:ext>
+          </a:extLst>
+        </p:cNvPr>
+        <p:cNvGrpSpPr/>
+        <p:nvPr/>
+      </p:nvGrpSpPr>
+      <p:grpSpPr>
+        <a:xfrm>
+          <a:off x="0" y="0"/>
+          <a:ext cx="0" cy="0"/>
+          <a:chOff x="0" y="0"/>
+          <a:chExt cx="0" cy="0"/>
+        </a:xfrm>
+      </p:grpSpPr>
+      <p:sp>
+        <p:nvSpPr>
+          <p:cNvPr id="2" name="TextBox 1">
+            <a:extLst>
+              <a:ext uri="{FF2B5EF4-FFF2-40B4-BE49-F238E27FC236}">
+                <a16:creationId xmlns:a16="http://schemas.microsoft.com/office/drawing/2014/main" id="{7E736EAC-CAF8-BB81-8090-E1511824DA1F}"/>
+              </a:ext>
+            </a:extLst>
+          </p:cNvPr>
+          <p:cNvSpPr txBox="1"/>
+          <p:nvPr/>
+        </p:nvSpPr>
+        <p:spPr>
+          <a:xfrm>
+            <a:off x="457200" y="457200"/>
+            <a:ext cx="8229600" cy="914400"/>
+          </a:xfrm>
+          <a:prstGeom prst="rect">
+            <a:avLst/>
+          </a:prstGeom>
+          <a:noFill/>
+        </p:spPr>
+        <p:txBody>
+          <a:bodyPr wrap="square">
+            <a:spAutoFit/>
+          </a:bodyPr>
+          <a:lstStyle/>
+          <a:p>
+            <a:pPr algn="ctr">
+              <a:defRPr sz="4000" b="1">
+                <a:solidFill>
+                  <a:srgbClr val="2C3E50"/>
+                </a:solidFill>
+                <a:latin typeface="Calibri"/>
+              </a:defRPr>
+            </a:pPr>
+            <a:r>
+              <a:t>User Engagement</a:t>
+            </a:r>
+          </a:p>
+        </p:txBody>
+      </p:sp>
+      <p:sp>
+        <p:nvSpPr>
+          <p:cNvPr id="4" name="Rounded Rectangle 3">
+            <a:extLst>
+              <a:ext uri="{FF2B5EF4-FFF2-40B4-BE49-F238E27FC236}">
+                <a16:creationId xmlns:a16="http://schemas.microsoft.com/office/drawing/2014/main" id="{E766D857-BD40-DEF7-8D72-D298874F098C}"/>
+              </a:ext>
+            </a:extLst>
+          </p:cNvPr>
+          <p:cNvSpPr/>
+          <p:nvPr/>
+        </p:nvSpPr>
+        <p:spPr>
+          <a:xfrm>
+            <a:off x="6492240" y="1645920"/>
+            <a:ext cx="2194560" cy="1188720"/>
+          </a:xfrm>
+          <a:prstGeom prst="roundRect">
+            <a:avLst/>
+          </a:prstGeom>
+          <a:solidFill>
+            <a:srgbClr val="F8F9FA"/>
+          </a:solidFill>
+          <a:ln w="6350">
+            <a:solidFill>
+              <a:srgbClr val="ECF0F1"/>
+            </a:solidFill>
+          </a:ln>
+          <a:effectLst/>
+        </p:spPr>
+        <p:style>
+          <a:lnRef idx="1">
+            <a:schemeClr val="accent1"/>
+          </a:lnRef>
+          <a:fillRef idx="3">
+            <a:schemeClr val="accent1"/>
+          </a:fillRef>
+          <a:effectRef idx="2">
+            <a:schemeClr val="accent1"/>
+          </a:effectRef>
+          <a:fontRef idx="minor">
+            <a:schemeClr val="lt1"/>
+          </a:fontRef>
+        </p:style>
+        <p:txBody>
+          <a:bodyPr rtlCol="0" anchor="ctr"/>
+          <a:lstStyle/>
+          <a:p>
+            <a:pPr algn="ctr"/>
+            <a:endParaRPr/>
+          </a:p>
+        </p:txBody>
+      </p:sp>
+      <p:sp>
+        <p:nvSpPr>
+          <p:cNvPr id="5" name="TextBox 4">
+            <a:extLst>
+              <a:ext uri="{FF2B5EF4-FFF2-40B4-BE49-F238E27FC236}">
+                <a16:creationId xmlns:a16="http://schemas.microsoft.com/office/drawing/2014/main" id="{D95E2601-467A-31D5-DE46-483F7D5EFE9A}"/>
+              </a:ext>
+            </a:extLst>
+          </p:cNvPr>
+          <p:cNvSpPr txBox="1"/>
+          <p:nvPr/>
+        </p:nvSpPr>
+        <p:spPr>
+          <a:xfrm>
+            <a:off x="6492240" y="1641455"/>
+            <a:ext cx="2194560" cy="731520"/>
+          </a:xfrm>
+          <a:prstGeom prst="rect">
+            <a:avLst/>
+          </a:prstGeom>
+          <a:noFill/>
+        </p:spPr>
+        <p:txBody>
+          <a:bodyPr wrap="none">
+            <a:spAutoFit/>
+          </a:bodyPr>
+          <a:lstStyle/>
+          <a:p>
+            <a:pPr algn="ctr">
+              <a:defRPr sz="3600" b="1">
+                <a:solidFill>
+                  <a:srgbClr val="3498DB"/>
+                </a:solidFill>
+                <a:latin typeface="Calibri"/>
+              </a:defRPr>
+            </a:pPr>
+            <a:r>
+              <a:rPr dirty="0"/>
+              <a:t>9.1</a:t>
+            </a:r>
+          </a:p>
+        </p:txBody>
+      </p:sp>
+      <p:sp>
+        <p:nvSpPr>
+          <p:cNvPr id="6" name="TextBox 5">
+            <a:extLst>
+              <a:ext uri="{FF2B5EF4-FFF2-40B4-BE49-F238E27FC236}">
+                <a16:creationId xmlns:a16="http://schemas.microsoft.com/office/drawing/2014/main" id="{C1E123CF-BDA8-5408-FA25-44B1D04963B6}"/>
+              </a:ext>
+            </a:extLst>
+          </p:cNvPr>
+          <p:cNvSpPr txBox="1"/>
+          <p:nvPr/>
+        </p:nvSpPr>
+        <p:spPr>
+          <a:xfrm>
+            <a:off x="7072166" y="2170501"/>
+            <a:ext cx="1034707" cy="584775"/>
+          </a:xfrm>
+          <a:prstGeom prst="rect">
+            <a:avLst/>
+          </a:prstGeom>
+          <a:noFill/>
+        </p:spPr>
+        <p:txBody>
+          <a:bodyPr wrap="none">
+            <a:spAutoFit/>
+          </a:bodyPr>
+          <a:lstStyle/>
+          <a:p>
+            <a:pPr algn="ctr">
+              <a:defRPr sz="1400">
+                <a:solidFill>
+                  <a:srgbClr val="7F8C8D"/>
+                </a:solidFill>
+                <a:latin typeface="Calibri"/>
+              </a:defRPr>
+            </a:pPr>
+            <a:r>
+              <a:rPr dirty="0"/>
+              <a:t>Mean DAU</a:t>
+            </a:r>
+          </a:p>
+          <a:p>
+            <a:pPr algn="ctr"/>
+            <a:r>
+              <a:rPr lang="en-US" dirty="0"/>
+              <a:t> </a:t>
+            </a:r>
+            <a:r>
+              <a:rPr dirty="0"/>
+              <a:t>[8.6-9.6]</a:t>
+            </a:r>
+          </a:p>
+        </p:txBody>
+      </p:sp>
+      <p:sp>
+        <p:nvSpPr>
+          <p:cNvPr id="7" name="Rounded Rectangle 6">
+            <a:extLst>
+              <a:ext uri="{FF2B5EF4-FFF2-40B4-BE49-F238E27FC236}">
+                <a16:creationId xmlns:a16="http://schemas.microsoft.com/office/drawing/2014/main" id="{0EAA6473-CCA8-BF0D-7CAE-AF62669B053F}"/>
+              </a:ext>
+            </a:extLst>
+          </p:cNvPr>
+          <p:cNvSpPr/>
+          <p:nvPr/>
+        </p:nvSpPr>
+        <p:spPr>
+          <a:xfrm>
+            <a:off x="6492240" y="3108960"/>
+            <a:ext cx="2194560" cy="1188720"/>
+          </a:xfrm>
+          <a:prstGeom prst="roundRect">
+            <a:avLst/>
+          </a:prstGeom>
+          <a:solidFill>
+            <a:srgbClr val="F8F9FA"/>
+          </a:solidFill>
+          <a:ln w="6350">
+            <a:solidFill>
+              <a:srgbClr val="ECF0F1"/>
+            </a:solidFill>
+          </a:ln>
+          <a:effectLst/>
+        </p:spPr>
+        <p:style>
+          <a:lnRef idx="1">
+            <a:schemeClr val="accent1"/>
+          </a:lnRef>
+          <a:fillRef idx="3">
+            <a:schemeClr val="accent1"/>
+          </a:fillRef>
+          <a:effectRef idx="2">
+            <a:schemeClr val="accent1"/>
+          </a:effectRef>
+          <a:fontRef idx="minor">
+            <a:schemeClr val="lt1"/>
+          </a:fontRef>
+        </p:style>
+        <p:txBody>
+          <a:bodyPr rtlCol="0" anchor="ctr"/>
+          <a:lstStyle/>
+          <a:p>
+            <a:pPr algn="ctr"/>
+            <a:endParaRPr/>
+          </a:p>
+        </p:txBody>
+      </p:sp>
+      <p:sp>
+        <p:nvSpPr>
+          <p:cNvPr id="8" name="TextBox 7">
+            <a:extLst>
+              <a:ext uri="{FF2B5EF4-FFF2-40B4-BE49-F238E27FC236}">
+                <a16:creationId xmlns:a16="http://schemas.microsoft.com/office/drawing/2014/main" id="{0ADE8C66-CD73-8713-2626-DDC14AFBE1E8}"/>
+              </a:ext>
+            </a:extLst>
+          </p:cNvPr>
+          <p:cNvSpPr txBox="1"/>
+          <p:nvPr/>
+        </p:nvSpPr>
+        <p:spPr>
+          <a:xfrm>
+            <a:off x="6492240" y="3104495"/>
+            <a:ext cx="2194560" cy="731520"/>
+          </a:xfrm>
+          <a:prstGeom prst="rect">
+            <a:avLst/>
+          </a:prstGeom>
+          <a:noFill/>
+        </p:spPr>
+        <p:txBody>
+          <a:bodyPr wrap="none">
+            <a:spAutoFit/>
+          </a:bodyPr>
+          <a:lstStyle/>
+          <a:p>
+            <a:pPr algn="ctr">
+              <a:defRPr sz="3600" b="1">
+                <a:solidFill>
+                  <a:srgbClr val="3498DB"/>
+                </a:solidFill>
+                <a:latin typeface="Calibri"/>
+              </a:defRPr>
+            </a:pPr>
+            <a:r>
+              <a:rPr dirty="0"/>
+              <a:t>88.8</a:t>
+            </a:r>
+          </a:p>
+        </p:txBody>
+      </p:sp>
+      <p:sp>
+        <p:nvSpPr>
+          <p:cNvPr id="9" name="TextBox 8">
+            <a:extLst>
+              <a:ext uri="{FF2B5EF4-FFF2-40B4-BE49-F238E27FC236}">
+                <a16:creationId xmlns:a16="http://schemas.microsoft.com/office/drawing/2014/main" id="{8E9368E7-DA3F-88E6-9BD6-DF5B753D2D74}"/>
+              </a:ext>
+            </a:extLst>
+          </p:cNvPr>
+          <p:cNvSpPr txBox="1"/>
+          <p:nvPr/>
+        </p:nvSpPr>
+        <p:spPr>
+          <a:xfrm>
+            <a:off x="6929723" y="3656073"/>
+            <a:ext cx="1319592" cy="584775"/>
+          </a:xfrm>
+          <a:prstGeom prst="rect">
+            <a:avLst/>
+          </a:prstGeom>
+          <a:noFill/>
+        </p:spPr>
+        <p:txBody>
+          <a:bodyPr wrap="none">
+            <a:spAutoFit/>
+          </a:bodyPr>
+          <a:lstStyle/>
+          <a:p>
+            <a:pPr algn="ctr">
+              <a:defRPr sz="1400">
+                <a:solidFill>
+                  <a:srgbClr val="7F8C8D"/>
+                </a:solidFill>
+                <a:latin typeface="Calibri"/>
+              </a:defRPr>
+            </a:pPr>
+            <a:r>
+              <a:rPr dirty="0"/>
+              <a:t>Mean MAU</a:t>
+            </a:r>
+          </a:p>
+          <a:p>
+            <a:pPr algn="ctr"/>
+            <a:r>
+              <a:rPr lang="en-US" dirty="0"/>
+              <a:t>  </a:t>
+            </a:r>
+            <a:r>
+              <a:rPr dirty="0"/>
+              <a:t>[82.8-94.7]</a:t>
+            </a:r>
+          </a:p>
+        </p:txBody>
+      </p:sp>
+      <p:sp>
+        <p:nvSpPr>
+          <p:cNvPr id="10" name="Rounded Rectangle 9">
+            <a:extLst>
+              <a:ext uri="{FF2B5EF4-FFF2-40B4-BE49-F238E27FC236}">
+                <a16:creationId xmlns:a16="http://schemas.microsoft.com/office/drawing/2014/main" id="{0648DCEA-9B4F-F46B-21B5-DEE0EBD77A48}"/>
+              </a:ext>
+            </a:extLst>
+          </p:cNvPr>
+          <p:cNvSpPr/>
+          <p:nvPr/>
+        </p:nvSpPr>
+        <p:spPr>
+          <a:xfrm>
+            <a:off x="6492240" y="4572000"/>
+            <a:ext cx="2194560" cy="1188720"/>
+          </a:xfrm>
+          <a:prstGeom prst="roundRect">
+            <a:avLst/>
+          </a:prstGeom>
+          <a:solidFill>
+            <a:srgbClr val="F8F9FA"/>
+          </a:solidFill>
+          <a:ln w="6350">
+            <a:solidFill>
+              <a:srgbClr val="ECF0F1"/>
+            </a:solidFill>
+          </a:ln>
+          <a:effectLst/>
+        </p:spPr>
+        <p:style>
+          <a:lnRef idx="1">
+            <a:schemeClr val="accent1"/>
+          </a:lnRef>
+          <a:fillRef idx="3">
+            <a:schemeClr val="accent1"/>
+          </a:fillRef>
+          <a:effectRef idx="2">
+            <a:schemeClr val="accent1"/>
+          </a:effectRef>
+          <a:fontRef idx="minor">
+            <a:schemeClr val="lt1"/>
+          </a:fontRef>
+        </p:style>
+        <p:txBody>
+          <a:bodyPr rtlCol="0" anchor="ctr"/>
+          <a:lstStyle/>
+          <a:p>
+            <a:pPr algn="ctr"/>
+            <a:endParaRPr/>
+          </a:p>
+        </p:txBody>
+      </p:sp>
+      <p:sp>
+        <p:nvSpPr>
+          <p:cNvPr id="11" name="TextBox 10">
+            <a:extLst>
+              <a:ext uri="{FF2B5EF4-FFF2-40B4-BE49-F238E27FC236}">
+                <a16:creationId xmlns:a16="http://schemas.microsoft.com/office/drawing/2014/main" id="{C614FF0B-51FF-3A62-8191-40D333F0336D}"/>
+              </a:ext>
+            </a:extLst>
+          </p:cNvPr>
+          <p:cNvSpPr txBox="1"/>
+          <p:nvPr/>
+        </p:nvSpPr>
+        <p:spPr>
+          <a:xfrm>
+            <a:off x="6492240" y="4638913"/>
+            <a:ext cx="2194560" cy="731520"/>
+          </a:xfrm>
+          <a:prstGeom prst="rect">
+            <a:avLst/>
+          </a:prstGeom>
+          <a:noFill/>
+        </p:spPr>
+        <p:txBody>
+          <a:bodyPr wrap="none">
+            <a:spAutoFit/>
+          </a:bodyPr>
+          <a:lstStyle/>
+          <a:p>
+            <a:pPr algn="ctr">
+              <a:defRPr sz="3600" b="1">
+                <a:solidFill>
+                  <a:srgbClr val="3498DB"/>
+                </a:solidFill>
+                <a:latin typeface="Calibri"/>
+              </a:defRPr>
+            </a:pPr>
+            <a:r>
+              <a:rPr dirty="0"/>
+              <a:t>10.2%</a:t>
+            </a:r>
+          </a:p>
+        </p:txBody>
+      </p:sp>
+      <p:sp>
+        <p:nvSpPr>
+          <p:cNvPr id="12" name="TextBox 11">
+            <a:extLst>
+              <a:ext uri="{FF2B5EF4-FFF2-40B4-BE49-F238E27FC236}">
+                <a16:creationId xmlns:a16="http://schemas.microsoft.com/office/drawing/2014/main" id="{CB5C43F5-675C-C3A7-7110-D76A40C1EB65}"/>
+              </a:ext>
+            </a:extLst>
+          </p:cNvPr>
+          <p:cNvSpPr txBox="1"/>
+          <p:nvPr/>
+        </p:nvSpPr>
+        <p:spPr>
+          <a:xfrm>
+            <a:off x="6916484" y="5212080"/>
+            <a:ext cx="1313116" cy="307777"/>
+          </a:xfrm>
+          <a:prstGeom prst="rect">
+            <a:avLst/>
+          </a:prstGeom>
+          <a:noFill/>
+        </p:spPr>
+        <p:txBody>
+          <a:bodyPr wrap="none">
+            <a:spAutoFit/>
+          </a:bodyPr>
+          <a:lstStyle/>
+          <a:p>
+            <a:pPr algn="ctr">
+              <a:defRPr sz="1400">
+                <a:solidFill>
+                  <a:srgbClr val="7F8C8D"/>
+                </a:solidFill>
+                <a:latin typeface="Calibri"/>
+              </a:defRPr>
+            </a:pPr>
+            <a:r>
+              <a:rPr dirty="0"/>
+              <a:t>Stickiness</a:t>
+            </a:r>
+            <a:r>
+              <a:rPr lang="en-US" dirty="0"/>
+              <a:t> Ratio</a:t>
+            </a:r>
+            <a:endParaRPr dirty="0"/>
+          </a:p>
+        </p:txBody>
+      </p:sp>
+      <p:sp>
+        <p:nvSpPr>
+          <p:cNvPr id="13" name="TextBox 12">
+            <a:extLst>
+              <a:ext uri="{FF2B5EF4-FFF2-40B4-BE49-F238E27FC236}">
+                <a16:creationId xmlns:a16="http://schemas.microsoft.com/office/drawing/2014/main" id="{DD414458-1250-9748-086C-B9D625CEDBFC}"/>
+              </a:ext>
+            </a:extLst>
+          </p:cNvPr>
+          <p:cNvSpPr txBox="1"/>
+          <p:nvPr/>
+        </p:nvSpPr>
+        <p:spPr>
+          <a:xfrm>
+            <a:off x="914400" y="6217920"/>
+            <a:ext cx="7315200" cy="457200"/>
+          </a:xfrm>
+          <a:prstGeom prst="rect">
+            <a:avLst/>
+          </a:prstGeom>
+          <a:noFill/>
+        </p:spPr>
+        <p:txBody>
+          <a:bodyPr wrap="square" anchor="t">
+            <a:spAutoFit/>
+          </a:bodyPr>
+          <a:lstStyle/>
+          <a:p>
+            <a:pPr algn="ctr">
+              <a:defRPr sz="1600" b="0">
+                <a:solidFill>
+                  <a:srgbClr val="7F8C8D"/>
+                </a:solidFill>
+                <a:latin typeface="Calibri"/>
+              </a:defRPr>
+            </a:pPr>
+            <a:r>
+              <a:rPr dirty="0"/>
+              <a:t>Stable engagement with 12.5 sessions per user throughout 2022</a:t>
+            </a:r>
+          </a:p>
+        </p:txBody>
+      </p:sp>
+      <p:sp>
+        <p:nvSpPr>
+          <p:cNvPr id="14" name="TextBox 13">
+            <a:extLst>
+              <a:ext uri="{FF2B5EF4-FFF2-40B4-BE49-F238E27FC236}">
+                <a16:creationId xmlns:a16="http://schemas.microsoft.com/office/drawing/2014/main" id="{381D3E09-8540-A0E2-577A-04A4325B6EB4}"/>
+              </a:ext>
+            </a:extLst>
+          </p:cNvPr>
+          <p:cNvSpPr txBox="1"/>
+          <p:nvPr/>
+        </p:nvSpPr>
+        <p:spPr>
+          <a:xfrm>
+            <a:off x="8229600" y="6492240"/>
+            <a:ext cx="731520" cy="274320"/>
+          </a:xfrm>
+          <a:prstGeom prst="rect">
+            <a:avLst/>
+          </a:prstGeom>
+          <a:noFill/>
+        </p:spPr>
+        <p:txBody>
+          <a:bodyPr wrap="none">
+            <a:spAutoFit/>
+          </a:bodyPr>
+          <a:lstStyle/>
+          <a:p>
+            <a:pPr algn="r">
+              <a:defRPr sz="1000">
+                <a:solidFill>
+                  <a:srgbClr val="7F8C8D"/>
+                </a:solidFill>
+                <a:latin typeface="Calibri"/>
+              </a:defRPr>
+            </a:pPr>
+            <a:r>
+              <a:t>5/10</a:t>
+            </a:r>
+          </a:p>
+        </p:txBody>
+      </p:sp>
+      <p:sp>
+        <p:nvSpPr>
+          <p:cNvPr id="15" name="TextBox 14">
+            <a:extLst>
+              <a:ext uri="{FF2B5EF4-FFF2-40B4-BE49-F238E27FC236}">
+                <a16:creationId xmlns:a16="http://schemas.microsoft.com/office/drawing/2014/main" id="{A87BD1F6-6980-94DE-C21D-13801CBDFFE4}"/>
+              </a:ext>
+            </a:extLst>
+          </p:cNvPr>
+          <p:cNvSpPr txBox="1"/>
+          <p:nvPr/>
+        </p:nvSpPr>
+        <p:spPr>
+          <a:xfrm>
+            <a:off x="890111" y="5320022"/>
+            <a:ext cx="4986338" cy="369332"/>
+          </a:xfrm>
+          <a:prstGeom prst="rect">
+            <a:avLst/>
+          </a:prstGeom>
+          <a:noFill/>
+        </p:spPr>
+        <p:txBody>
+          <a:bodyPr wrap="square" rtlCol="0">
+            <a:spAutoFit/>
+          </a:bodyPr>
+          <a:lstStyle/>
+          <a:p>
+            <a:r>
+              <a:rPr lang="en-US" dirty="0"/>
+              <a:t>Significant Surge Since July 2022</a:t>
+            </a:r>
+          </a:p>
+        </p:txBody>
+      </p:sp>
+      <p:pic>
+        <p:nvPicPr>
+          <p:cNvPr id="17" name="Picture 16" descr="A graph of blue bars&#10;&#10;AI-generated content may be incorrect.">
+            <a:extLst>
+              <a:ext uri="{FF2B5EF4-FFF2-40B4-BE49-F238E27FC236}">
+                <a16:creationId xmlns:a16="http://schemas.microsoft.com/office/drawing/2014/main" id="{6ABC5E92-C6C4-633C-47C6-F98B8A9FDD5A}"/>
+              </a:ext>
+            </a:extLst>
+          </p:cNvPr>
+          <p:cNvPicPr>
+            <a:picLocks noChangeAspect="1"/>
+          </p:cNvPicPr>
+          <p:nvPr/>
+        </p:nvPicPr>
+        <p:blipFill>
+          <a:blip r:embed="rId2"/>
+          <a:stretch>
+            <a:fillRect/>
+          </a:stretch>
+        </p:blipFill>
+        <p:spPr>
+          <a:xfrm>
+            <a:off x="238459" y="1562752"/>
+            <a:ext cx="6220825" cy="3732495"/>
+          </a:xfrm>
+          <a:prstGeom prst="rect">
+            <a:avLst/>
+          </a:prstGeom>
+        </p:spPr>
+      </p:pic>
+    </p:spTree>
+    <p:extLst>
+      <p:ext uri="{BB962C8B-B14F-4D97-AF65-F5344CB8AC3E}">
+        <p14:creationId xmlns:p14="http://schemas.microsoft.com/office/powerpoint/2010/main" val="1520348894"/>
+      </p:ext>
+    </p:extLst>
+  </p:cSld>
+  <p:clrMapOvr>
+    <a:masterClrMapping/>
+  </p:clrMapOvr>
+</p:sld>
+</file>
+
+<file path=ppt/slides/slide7.xml><?xml version="1.0" encoding="utf-8"?>
+<p:sld xmlns:a="http://schemas.openxmlformats.org/drawingml/2006/main" xmlns:r="http://schemas.openxmlformats.org/officeDocument/2006/relationships" xmlns:p="http://schemas.openxmlformats.org/presentationml/2006/main">
+  <p:cSld>
+    <p:spTree>
+      <p:nvGrpSpPr>
         <p:cNvPr id="1" name=""/>
         <p:cNvGrpSpPr/>
         <p:nvPr/>
@@ -7857,642 +9159,6 @@
             </a:pPr>
             <a:r>
               <a:t>6/10</a:t>
-            </a:r>
-          </a:p>
-        </p:txBody>
-      </p:sp>
-    </p:spTree>
-  </p:cSld>
-  <p:clrMapOvr>
-    <a:masterClrMapping/>
-  </p:clrMapOvr>
-</p:sld>
-</file>
-
-<file path=ppt/slides/slide7.xml><?xml version="1.0" encoding="utf-8"?>
-<p:sld xmlns:a="http://schemas.openxmlformats.org/drawingml/2006/main" xmlns:r="http://schemas.openxmlformats.org/officeDocument/2006/relationships" xmlns:p="http://schemas.openxmlformats.org/presentationml/2006/main">
-  <p:cSld>
-    <p:spTree>
-      <p:nvGrpSpPr>
-        <p:cNvPr id="1" name=""/>
-        <p:cNvGrpSpPr/>
-        <p:nvPr/>
-      </p:nvGrpSpPr>
-      <p:grpSpPr>
-        <a:xfrm>
-          <a:off x="0" y="0"/>
-          <a:ext cx="0" cy="0"/>
-          <a:chOff x="0" y="0"/>
-          <a:chExt cx="0" cy="0"/>
-        </a:xfrm>
-      </p:grpSpPr>
-      <p:sp>
-        <p:nvSpPr>
-          <p:cNvPr id="2" name="TextBox 1"/>
-          <p:cNvSpPr txBox="1"/>
-          <p:nvPr/>
-        </p:nvSpPr>
-        <p:spPr>
-          <a:xfrm>
-            <a:off x="457200" y="457200"/>
-            <a:ext cx="8229600" cy="914400"/>
-          </a:xfrm>
-          <a:prstGeom prst="rect">
-            <a:avLst/>
-          </a:prstGeom>
-          <a:noFill/>
-        </p:spPr>
-        <p:txBody>
-          <a:bodyPr wrap="square">
-            <a:spAutoFit/>
-          </a:bodyPr>
-          <a:lstStyle/>
-          <a:p>
-            <a:pPr algn="ctr">
-              <a:defRPr sz="4000" b="1">
-                <a:solidFill>
-                  <a:srgbClr val="2C3E50"/>
-                </a:solidFill>
-                <a:latin typeface="Calibri"/>
-              </a:defRPr>
-            </a:pPr>
-            <a:r>
-              <a:t>Monetization Success</a:t>
-            </a:r>
-          </a:p>
-        </p:txBody>
-      </p:sp>
-      <p:sp>
-        <p:nvSpPr>
-          <p:cNvPr id="3" name="Rounded Rectangle 2"/>
-          <p:cNvSpPr/>
-          <p:nvPr/>
-        </p:nvSpPr>
-        <p:spPr>
-          <a:xfrm>
-            <a:off x="1097280" y="1463040"/>
-            <a:ext cx="1554480" cy="1005840"/>
-          </a:xfrm>
-          <a:prstGeom prst="roundRect">
-            <a:avLst/>
-          </a:prstGeom>
-          <a:solidFill>
-            <a:srgbClr val="F8F9FA"/>
-          </a:solidFill>
-          <a:ln w="6350">
-            <a:solidFill>
-              <a:srgbClr val="ECF0F1"/>
-            </a:solidFill>
-          </a:ln>
-          <a:effectLst/>
-        </p:spPr>
-        <p:style>
-          <a:lnRef idx="1">
-            <a:schemeClr val="accent1"/>
-          </a:lnRef>
-          <a:fillRef idx="3">
-            <a:schemeClr val="accent1"/>
-          </a:fillRef>
-          <a:effectRef idx="2">
-            <a:schemeClr val="accent1"/>
-          </a:effectRef>
-          <a:fontRef idx="minor">
-            <a:schemeClr val="lt1"/>
-          </a:fontRef>
-        </p:style>
-        <p:txBody>
-          <a:bodyPr rtlCol="0" anchor="ctr"/>
-          <a:lstStyle/>
-          <a:p>
-            <a:pPr algn="ctr"/>
-            <a:endParaRPr/>
-          </a:p>
-        </p:txBody>
-      </p:sp>
-      <p:sp>
-        <p:nvSpPr>
-          <p:cNvPr id="4" name="TextBox 3"/>
-          <p:cNvSpPr txBox="1"/>
-          <p:nvPr/>
-        </p:nvSpPr>
-        <p:spPr>
-          <a:xfrm>
-            <a:off x="1097280" y="1600200"/>
-            <a:ext cx="1554480" cy="731520"/>
-          </a:xfrm>
-          <a:prstGeom prst="rect">
-            <a:avLst/>
-          </a:prstGeom>
-          <a:noFill/>
-        </p:spPr>
-        <p:txBody>
-          <a:bodyPr wrap="none">
-            <a:spAutoFit/>
-          </a:bodyPr>
-          <a:lstStyle/>
-          <a:p>
-            <a:pPr algn="ctr">
-              <a:defRPr sz="3600" b="1">
-                <a:solidFill>
-                  <a:srgbClr val="2ECC71"/>
-                </a:solidFill>
-                <a:latin typeface="Calibri"/>
-              </a:defRPr>
-            </a:pPr>
-            <a:r>
-              <a:rPr dirty="0"/>
-              <a:t>$10.86</a:t>
-            </a:r>
-          </a:p>
-        </p:txBody>
-      </p:sp>
-      <p:sp>
-        <p:nvSpPr>
-          <p:cNvPr id="5" name="TextBox 4"/>
-          <p:cNvSpPr txBox="1"/>
-          <p:nvPr/>
-        </p:nvSpPr>
-        <p:spPr>
-          <a:xfrm>
-            <a:off x="1097280" y="2560320"/>
-            <a:ext cx="1554480" cy="365760"/>
-          </a:xfrm>
-          <a:prstGeom prst="rect">
-            <a:avLst/>
-          </a:prstGeom>
-          <a:noFill/>
-        </p:spPr>
-        <p:txBody>
-          <a:bodyPr wrap="none">
-            <a:spAutoFit/>
-          </a:bodyPr>
-          <a:lstStyle/>
-          <a:p>
-            <a:pPr algn="ctr">
-              <a:defRPr sz="1400">
-                <a:solidFill>
-                  <a:srgbClr val="7F8C8D"/>
-                </a:solidFill>
-                <a:latin typeface="Calibri"/>
-              </a:defRPr>
-            </a:pPr>
-            <a:r>
-              <a:t>ARPU</a:t>
-            </a:r>
-          </a:p>
-        </p:txBody>
-      </p:sp>
-      <p:sp>
-        <p:nvSpPr>
-          <p:cNvPr id="6" name="Rounded Rectangle 5"/>
-          <p:cNvSpPr/>
-          <p:nvPr/>
-        </p:nvSpPr>
-        <p:spPr>
-          <a:xfrm>
-            <a:off x="2926080" y="1463040"/>
-            <a:ext cx="1554480" cy="1005840"/>
-          </a:xfrm>
-          <a:prstGeom prst="roundRect">
-            <a:avLst/>
-          </a:prstGeom>
-          <a:solidFill>
-            <a:srgbClr val="F8F9FA"/>
-          </a:solidFill>
-          <a:ln w="6350">
-            <a:solidFill>
-              <a:srgbClr val="ECF0F1"/>
-            </a:solidFill>
-          </a:ln>
-          <a:effectLst/>
-        </p:spPr>
-        <p:style>
-          <a:lnRef idx="1">
-            <a:schemeClr val="accent1"/>
-          </a:lnRef>
-          <a:fillRef idx="3">
-            <a:schemeClr val="accent1"/>
-          </a:fillRef>
-          <a:effectRef idx="2">
-            <a:schemeClr val="accent1"/>
-          </a:effectRef>
-          <a:fontRef idx="minor">
-            <a:schemeClr val="lt1"/>
-          </a:fontRef>
-        </p:style>
-        <p:txBody>
-          <a:bodyPr rtlCol="0" anchor="ctr"/>
-          <a:lstStyle/>
-          <a:p>
-            <a:pPr algn="ctr"/>
-            <a:endParaRPr/>
-          </a:p>
-        </p:txBody>
-      </p:sp>
-      <p:sp>
-        <p:nvSpPr>
-          <p:cNvPr id="7" name="TextBox 6"/>
-          <p:cNvSpPr txBox="1"/>
-          <p:nvPr/>
-        </p:nvSpPr>
-        <p:spPr>
-          <a:xfrm>
-            <a:off x="2926080" y="1600200"/>
-            <a:ext cx="1554480" cy="731520"/>
-          </a:xfrm>
-          <a:prstGeom prst="rect">
-            <a:avLst/>
-          </a:prstGeom>
-          <a:noFill/>
-        </p:spPr>
-        <p:txBody>
-          <a:bodyPr wrap="none">
-            <a:spAutoFit/>
-          </a:bodyPr>
-          <a:lstStyle/>
-          <a:p>
-            <a:pPr algn="ctr">
-              <a:defRPr sz="3600" b="1">
-                <a:solidFill>
-                  <a:srgbClr val="2ECC71"/>
-                </a:solidFill>
-                <a:latin typeface="Calibri"/>
-              </a:defRPr>
-            </a:pPr>
-            <a:r>
-              <a:rPr dirty="0"/>
-              <a:t>$21.07</a:t>
-            </a:r>
-          </a:p>
-        </p:txBody>
-      </p:sp>
-      <p:sp>
-        <p:nvSpPr>
-          <p:cNvPr id="8" name="TextBox 7"/>
-          <p:cNvSpPr txBox="1"/>
-          <p:nvPr/>
-        </p:nvSpPr>
-        <p:spPr>
-          <a:xfrm>
-            <a:off x="2926080" y="2560320"/>
-            <a:ext cx="1554480" cy="365760"/>
-          </a:xfrm>
-          <a:prstGeom prst="rect">
-            <a:avLst/>
-          </a:prstGeom>
-          <a:noFill/>
-        </p:spPr>
-        <p:txBody>
-          <a:bodyPr wrap="none">
-            <a:spAutoFit/>
-          </a:bodyPr>
-          <a:lstStyle/>
-          <a:p>
-            <a:pPr algn="ctr">
-              <a:defRPr sz="1400">
-                <a:solidFill>
-                  <a:srgbClr val="7F8C8D"/>
-                </a:solidFill>
-                <a:latin typeface="Calibri"/>
-              </a:defRPr>
-            </a:pPr>
-            <a:r>
-              <a:t>ARPPU</a:t>
-            </a:r>
-          </a:p>
-        </p:txBody>
-      </p:sp>
-      <p:sp>
-        <p:nvSpPr>
-          <p:cNvPr id="9" name="Rounded Rectangle 8"/>
-          <p:cNvSpPr/>
-          <p:nvPr/>
-        </p:nvSpPr>
-        <p:spPr>
-          <a:xfrm>
-            <a:off x="4754880" y="1463040"/>
-            <a:ext cx="1554480" cy="1005840"/>
-          </a:xfrm>
-          <a:prstGeom prst="roundRect">
-            <a:avLst/>
-          </a:prstGeom>
-          <a:solidFill>
-            <a:srgbClr val="F8F9FA"/>
-          </a:solidFill>
-          <a:ln w="6350">
-            <a:solidFill>
-              <a:srgbClr val="ECF0F1"/>
-            </a:solidFill>
-          </a:ln>
-          <a:effectLst/>
-        </p:spPr>
-        <p:style>
-          <a:lnRef idx="1">
-            <a:schemeClr val="accent1"/>
-          </a:lnRef>
-          <a:fillRef idx="3">
-            <a:schemeClr val="accent1"/>
-          </a:fillRef>
-          <a:effectRef idx="2">
-            <a:schemeClr val="accent1"/>
-          </a:effectRef>
-          <a:fontRef idx="minor">
-            <a:schemeClr val="lt1"/>
-          </a:fontRef>
-        </p:style>
-        <p:txBody>
-          <a:bodyPr rtlCol="0" anchor="ctr"/>
-          <a:lstStyle/>
-          <a:p>
-            <a:pPr algn="ctr"/>
-            <a:endParaRPr/>
-          </a:p>
-        </p:txBody>
-      </p:sp>
-      <p:sp>
-        <p:nvSpPr>
-          <p:cNvPr id="10" name="TextBox 9"/>
-          <p:cNvSpPr txBox="1"/>
-          <p:nvPr/>
-        </p:nvSpPr>
-        <p:spPr>
-          <a:xfrm>
-            <a:off x="4754880" y="1600200"/>
-            <a:ext cx="1554480" cy="731520"/>
-          </a:xfrm>
-          <a:prstGeom prst="rect">
-            <a:avLst/>
-          </a:prstGeom>
-          <a:noFill/>
-        </p:spPr>
-        <p:txBody>
-          <a:bodyPr wrap="none">
-            <a:spAutoFit/>
-          </a:bodyPr>
-          <a:lstStyle/>
-          <a:p>
-            <a:pPr algn="ctr">
-              <a:defRPr sz="3600" b="1">
-                <a:solidFill>
-                  <a:srgbClr val="2ECC71"/>
-                </a:solidFill>
-                <a:latin typeface="Calibri"/>
-              </a:defRPr>
-            </a:pPr>
-            <a:r>
-              <a:t>51.5%</a:t>
-            </a:r>
-          </a:p>
-        </p:txBody>
-      </p:sp>
-      <p:sp>
-        <p:nvSpPr>
-          <p:cNvPr id="11" name="TextBox 10"/>
-          <p:cNvSpPr txBox="1"/>
-          <p:nvPr/>
-        </p:nvSpPr>
-        <p:spPr>
-          <a:xfrm>
-            <a:off x="4754880" y="2560320"/>
-            <a:ext cx="1554480" cy="365760"/>
-          </a:xfrm>
-          <a:prstGeom prst="rect">
-            <a:avLst/>
-          </a:prstGeom>
-          <a:noFill/>
-        </p:spPr>
-        <p:txBody>
-          <a:bodyPr wrap="none">
-            <a:spAutoFit/>
-          </a:bodyPr>
-          <a:lstStyle/>
-          <a:p>
-            <a:pPr algn="ctr">
-              <a:defRPr sz="1400">
-                <a:solidFill>
-                  <a:srgbClr val="7F8C8D"/>
-                </a:solidFill>
-                <a:latin typeface="Calibri"/>
-              </a:defRPr>
-            </a:pPr>
-            <a:r>
-              <a:t>Conversion</a:t>
-            </a:r>
-          </a:p>
-        </p:txBody>
-      </p:sp>
-      <p:sp>
-        <p:nvSpPr>
-          <p:cNvPr id="12" name="Rounded Rectangle 11"/>
-          <p:cNvSpPr/>
-          <p:nvPr/>
-        </p:nvSpPr>
-        <p:spPr>
-          <a:xfrm>
-            <a:off x="6583680" y="1463040"/>
-            <a:ext cx="1554480" cy="1005840"/>
-          </a:xfrm>
-          <a:prstGeom prst="roundRect">
-            <a:avLst/>
-          </a:prstGeom>
-          <a:solidFill>
-            <a:srgbClr val="F8F9FA"/>
-          </a:solidFill>
-          <a:ln w="6350">
-            <a:solidFill>
-              <a:srgbClr val="ECF0F1"/>
-            </a:solidFill>
-          </a:ln>
-          <a:effectLst/>
-        </p:spPr>
-        <p:style>
-          <a:lnRef idx="1">
-            <a:schemeClr val="accent1"/>
-          </a:lnRef>
-          <a:fillRef idx="3">
-            <a:schemeClr val="accent1"/>
-          </a:fillRef>
-          <a:effectRef idx="2">
-            <a:schemeClr val="accent1"/>
-          </a:effectRef>
-          <a:fontRef idx="minor">
-            <a:schemeClr val="lt1"/>
-          </a:fontRef>
-        </p:style>
-        <p:txBody>
-          <a:bodyPr rtlCol="0" anchor="ctr"/>
-          <a:lstStyle/>
-          <a:p>
-            <a:pPr algn="ctr"/>
-            <a:endParaRPr/>
-          </a:p>
-        </p:txBody>
-      </p:sp>
-      <p:sp>
-        <p:nvSpPr>
-          <p:cNvPr id="13" name="TextBox 12"/>
-          <p:cNvSpPr txBox="1"/>
-          <p:nvPr/>
-        </p:nvSpPr>
-        <p:spPr>
-          <a:xfrm>
-            <a:off x="6583680" y="1600200"/>
-            <a:ext cx="1554480" cy="731520"/>
-          </a:xfrm>
-          <a:prstGeom prst="rect">
-            <a:avLst/>
-          </a:prstGeom>
-          <a:noFill/>
-        </p:spPr>
-        <p:txBody>
-          <a:bodyPr wrap="none">
-            <a:spAutoFit/>
-          </a:bodyPr>
-          <a:lstStyle/>
-          <a:p>
-            <a:pPr algn="ctr">
-              <a:defRPr sz="3600" b="1">
-                <a:solidFill>
-                  <a:srgbClr val="2ECC71"/>
-                </a:solidFill>
-                <a:latin typeface="Calibri"/>
-              </a:defRPr>
-            </a:pPr>
-            <a:r>
-              <a:t>$10.9K</a:t>
-            </a:r>
-          </a:p>
-        </p:txBody>
-      </p:sp>
-      <p:sp>
-        <p:nvSpPr>
-          <p:cNvPr id="14" name="TextBox 13"/>
-          <p:cNvSpPr txBox="1"/>
-          <p:nvPr/>
-        </p:nvSpPr>
-        <p:spPr>
-          <a:xfrm>
-            <a:off x="6583680" y="2560320"/>
-            <a:ext cx="1554480" cy="365760"/>
-          </a:xfrm>
-          <a:prstGeom prst="rect">
-            <a:avLst/>
-          </a:prstGeom>
-          <a:noFill/>
-        </p:spPr>
-        <p:txBody>
-          <a:bodyPr wrap="none">
-            <a:spAutoFit/>
-          </a:bodyPr>
-          <a:lstStyle/>
-          <a:p>
-            <a:pPr algn="ctr">
-              <a:defRPr sz="1400">
-                <a:solidFill>
-                  <a:srgbClr val="7F8C8D"/>
-                </a:solidFill>
-                <a:latin typeface="Calibri"/>
-              </a:defRPr>
-            </a:pPr>
-            <a:r>
-              <a:t>Total Revenue</a:t>
-            </a:r>
-          </a:p>
-        </p:txBody>
-      </p:sp>
-      <p:pic>
-        <p:nvPicPr>
-          <p:cNvPr id="15" name="Picture 14" descr="04_revenue_by_item.png"/>
-          <p:cNvPicPr>
-            <a:picLocks noChangeAspect="1"/>
-          </p:cNvPicPr>
-          <p:nvPr/>
-        </p:nvPicPr>
-        <p:blipFill>
-          <a:blip r:embed="rId2"/>
-          <a:stretch>
-            <a:fillRect/>
-          </a:stretch>
-        </p:blipFill>
-        <p:spPr>
-          <a:xfrm>
-            <a:off x="1737360" y="3017520"/>
-            <a:ext cx="5486400" cy="3291840"/>
-          </a:xfrm>
-          <a:prstGeom prst="rect">
-            <a:avLst/>
-          </a:prstGeom>
-        </p:spPr>
-      </p:pic>
-      <p:sp>
-        <p:nvSpPr>
-          <p:cNvPr id="16" name="TextBox 15"/>
-          <p:cNvSpPr txBox="1"/>
-          <p:nvPr/>
-        </p:nvSpPr>
-        <p:spPr>
-          <a:xfrm>
-            <a:off x="914400" y="6384175"/>
-            <a:ext cx="7315200" cy="457200"/>
-          </a:xfrm>
-          <a:prstGeom prst="rect">
-            <a:avLst/>
-          </a:prstGeom>
-          <a:noFill/>
-        </p:spPr>
-        <p:txBody>
-          <a:bodyPr wrap="square" anchor="t">
-            <a:spAutoFit/>
-          </a:bodyPr>
-          <a:lstStyle/>
-          <a:p>
-            <a:pPr algn="ctr">
-              <a:defRPr sz="1600" b="0">
-                <a:solidFill>
-                  <a:srgbClr val="7F8C8D"/>
-                </a:solidFill>
-                <a:latin typeface="Calibri"/>
-              </a:defRPr>
-            </a:pPr>
-            <a:r>
-              <a:rPr dirty="0"/>
-              <a:t>Diamond Pack ($49.99) drives 62% of revenue - premium monetization works</a:t>
-            </a:r>
-          </a:p>
-        </p:txBody>
-      </p:sp>
-      <p:sp>
-        <p:nvSpPr>
-          <p:cNvPr id="17" name="TextBox 16"/>
-          <p:cNvSpPr txBox="1"/>
-          <p:nvPr/>
-        </p:nvSpPr>
-        <p:spPr>
-          <a:xfrm>
-            <a:off x="8229600" y="6492240"/>
-            <a:ext cx="731520" cy="274320"/>
-          </a:xfrm>
-          <a:prstGeom prst="rect">
-            <a:avLst/>
-          </a:prstGeom>
-          <a:noFill/>
-        </p:spPr>
-        <p:txBody>
-          <a:bodyPr wrap="none">
-            <a:spAutoFit/>
-          </a:bodyPr>
-          <a:lstStyle/>
-          <a:p>
-            <a:pPr algn="r">
-              <a:defRPr sz="1000">
-                <a:solidFill>
-                  <a:srgbClr val="7F8C8D"/>
-                </a:solidFill>
-                <a:latin typeface="Calibri"/>
-              </a:defRPr>
-            </a:pPr>
-            <a:r>
-              <a:t>7/10</a:t>
             </a:r>
           </a:p>
         </p:txBody>
@@ -8522,36 +9188,6 @@
           <a:chExt cx="0" cy="0"/>
         </a:xfrm>
       </p:grpSpPr>
-      <p:pic>
-        <p:nvPicPr>
-          <p:cNvPr id="10" name="Picture 9" descr="A chart with numbers and a number of people&#10;&#10;AI-generated content may be incorrect.">
-            <a:extLst>
-              <a:ext uri="{FF2B5EF4-FFF2-40B4-BE49-F238E27FC236}">
-                <a16:creationId xmlns:a16="http://schemas.microsoft.com/office/drawing/2014/main" id="{EAE6632C-2896-68F4-8C3C-BE8606710AEF}"/>
-              </a:ext>
-            </a:extLst>
-          </p:cNvPr>
-          <p:cNvPicPr>
-            <a:picLocks noChangeAspect="1"/>
-          </p:cNvPicPr>
-          <p:nvPr/>
-        </p:nvPicPr>
-        <p:blipFill>
-          <a:blip r:embed="rId2"/>
-          <a:stretch>
-            <a:fillRect/>
-          </a:stretch>
-        </p:blipFill>
-        <p:spPr>
-          <a:xfrm>
-            <a:off x="-1" y="1595437"/>
-            <a:ext cx="6315076" cy="5262564"/>
-          </a:xfrm>
-          <a:prstGeom prst="rect">
-            <a:avLst/>
-          </a:prstGeom>
-        </p:spPr>
-      </p:pic>
       <p:sp>
         <p:nvSpPr>
           <p:cNvPr id="2" name="TextBox 1"/>
@@ -8583,21 +9219,21 @@
               </a:defRPr>
             </a:pPr>
             <a:r>
-              <a:t>High-Value Demographics</a:t>
-            </a:r>
-          </a:p>
-        </p:txBody>
-      </p:sp>
-      <p:sp>
-        <p:nvSpPr>
-          <p:cNvPr id="4" name="Rounded Rectangle 3"/>
+              <a:t>Monetization Success</a:t>
+            </a:r>
+          </a:p>
+        </p:txBody>
+      </p:sp>
+      <p:sp>
+        <p:nvSpPr>
+          <p:cNvPr id="3" name="Rounded Rectangle 2"/>
           <p:cNvSpPr/>
           <p:nvPr/>
         </p:nvSpPr>
         <p:spPr>
           <a:xfrm>
-            <a:off x="6315075" y="1645920"/>
-            <a:ext cx="2554605" cy="3883343"/>
+            <a:off x="1097280" y="1463040"/>
+            <a:ext cx="1554480" cy="1005840"/>
           </a:xfrm>
           <a:prstGeom prst="roundRect">
             <a:avLst/>
@@ -8606,50 +9242,11 @@
             <a:srgbClr val="F8F9FA"/>
           </a:solidFill>
           <a:ln w="6350">
-            <a:gradFill>
-              <a:gsLst>
-                <a:gs pos="0">
-                  <a:schemeClr val="accent1">
-                    <a:lumMod val="5000"/>
-                    <a:lumOff val="95000"/>
-                  </a:schemeClr>
-                </a:gs>
-                <a:gs pos="74000">
-                  <a:schemeClr val="accent1">
-                    <a:lumMod val="45000"/>
-                    <a:lumOff val="55000"/>
-                  </a:schemeClr>
-                </a:gs>
-                <a:gs pos="83000">
-                  <a:schemeClr val="accent1">
-                    <a:lumMod val="45000"/>
-                    <a:lumOff val="55000"/>
-                  </a:schemeClr>
-                </a:gs>
-                <a:gs pos="100000">
-                  <a:schemeClr val="accent1">
-                    <a:lumMod val="30000"/>
-                    <a:lumOff val="70000"/>
-                  </a:schemeClr>
-                </a:gs>
-              </a:gsLst>
-              <a:lin ang="3600000" scaled="0"/>
-            </a:gradFill>
+            <a:solidFill>
+              <a:srgbClr val="ECF0F1"/>
+            </a:solidFill>
           </a:ln>
-          <a:effectLst>
-            <a:glow rad="579646">
-              <a:schemeClr val="accent1">
-                <a:lumMod val="60000"/>
-                <a:lumOff val="40000"/>
-                <a:alpha val="5000"/>
-              </a:schemeClr>
-            </a:glow>
-            <a:outerShdw blurRad="387716" dist="38100" dir="2700000" algn="tl" rotWithShape="0">
-              <a:prstClr val="black">
-                <a:alpha val="4000"/>
-              </a:prstClr>
-            </a:outerShdw>
-          </a:effectLst>
+          <a:effectLst/>
         </p:spPr>
         <p:style>
           <a:lnRef idx="1">
@@ -8676,184 +9273,14 @@
       </p:sp>
       <p:sp>
         <p:nvSpPr>
-          <p:cNvPr id="5" name="TextBox 4"/>
+          <p:cNvPr id="4" name="TextBox 3"/>
           <p:cNvSpPr txBox="1"/>
           <p:nvPr/>
         </p:nvSpPr>
         <p:spPr>
           <a:xfrm>
-            <a:off x="6500812" y="2069226"/>
-            <a:ext cx="2185988" cy="3036729"/>
-          </a:xfrm>
-          <a:prstGeom prst="rect">
-            <a:avLst/>
-          </a:prstGeom>
-          <a:noFill/>
-        </p:spPr>
-        <p:txBody>
-          <a:bodyPr wrap="square">
-            <a:spAutoFit/>
-          </a:bodyPr>
-          <a:lstStyle/>
-          <a:p>
-            <a:pPr>
-              <a:spcAft>
-                <a:spcPts val="800"/>
-              </a:spcAft>
-              <a:defRPr sz="1600" b="1">
-                <a:solidFill>
-                  <a:srgbClr val="3498DB"/>
-                </a:solidFill>
-                <a:latin typeface="Calibri"/>
-              </a:defRPr>
-            </a:pPr>
-            <a:r>
-              <a:rPr dirty="0"/>
-              <a:t>Top Markets:</a:t>
-            </a:r>
-          </a:p>
-          <a:p>
-            <a:pPr>
-              <a:spcAft>
-                <a:spcPts val="800"/>
-              </a:spcAft>
-              <a:defRPr sz="1500">
-                <a:solidFill>
-                  <a:srgbClr val="212121"/>
-                </a:solidFill>
-                <a:latin typeface="Calibri"/>
-              </a:defRPr>
-            </a:pPr>
-            <a:r>
-              <a:rPr dirty="0"/>
-              <a:t>• Suriname: $39.19 ARPU</a:t>
-            </a:r>
-          </a:p>
-          <a:p>
-            <a:pPr>
-              <a:spcAft>
-                <a:spcPts val="800"/>
-              </a:spcAft>
-              <a:defRPr sz="1500">
-                <a:solidFill>
-                  <a:srgbClr val="212121"/>
-                </a:solidFill>
-                <a:latin typeface="Calibri"/>
-              </a:defRPr>
-            </a:pPr>
-            <a:r>
-              <a:rPr dirty="0"/>
-              <a:t>• Ireland: $22.98 ARPU</a:t>
-            </a:r>
-          </a:p>
-          <a:p>
-            <a:pPr>
-              <a:spcAft>
-                <a:spcPts val="800"/>
-              </a:spcAft>
-              <a:defRPr sz="1500">
-                <a:solidFill>
-                  <a:srgbClr val="212121"/>
-                </a:solidFill>
-                <a:latin typeface="Calibri"/>
-              </a:defRPr>
-            </a:pPr>
-            <a:endParaRPr dirty="0"/>
-          </a:p>
-          <a:p>
-            <a:pPr>
-              <a:spcAft>
-                <a:spcPts val="800"/>
-              </a:spcAft>
-              <a:defRPr sz="1600" b="1">
-                <a:solidFill>
-                  <a:srgbClr val="3498DB"/>
-                </a:solidFill>
-                <a:latin typeface="Calibri"/>
-              </a:defRPr>
-            </a:pPr>
-            <a:r>
-              <a:rPr dirty="0"/>
-              <a:t>Best Age Group:</a:t>
-            </a:r>
-          </a:p>
-          <a:p>
-            <a:pPr>
-              <a:spcAft>
-                <a:spcPts val="800"/>
-              </a:spcAft>
-              <a:defRPr sz="1500">
-                <a:solidFill>
-                  <a:srgbClr val="212121"/>
-                </a:solidFill>
-                <a:latin typeface="Calibri"/>
-              </a:defRPr>
-            </a:pPr>
-            <a:r>
-              <a:rPr dirty="0"/>
-              <a:t>• 18-25: $13.38 ARPU</a:t>
-            </a:r>
-          </a:p>
-          <a:p>
-            <a:pPr>
-              <a:spcAft>
-                <a:spcPts val="800"/>
-              </a:spcAft>
-              <a:defRPr sz="1500">
-                <a:solidFill>
-                  <a:srgbClr val="212121"/>
-                </a:solidFill>
-                <a:latin typeface="Calibri"/>
-              </a:defRPr>
-            </a:pPr>
-            <a:endParaRPr dirty="0"/>
-          </a:p>
-          <a:p>
-            <a:pPr>
-              <a:spcAft>
-                <a:spcPts val="800"/>
-              </a:spcAft>
-              <a:defRPr sz="1600" b="1">
-                <a:solidFill>
-                  <a:srgbClr val="3498DB"/>
-                </a:solidFill>
-                <a:latin typeface="Calibri"/>
-              </a:defRPr>
-            </a:pPr>
-            <a:r>
-              <a:rPr dirty="0"/>
-              <a:t>High-Value Profile:</a:t>
-            </a:r>
-          </a:p>
-          <a:p>
-            <a:pPr>
-              <a:spcAft>
-                <a:spcPts val="800"/>
-              </a:spcAft>
-              <a:defRPr sz="1500">
-                <a:solidFill>
-                  <a:srgbClr val="212121"/>
-                </a:solidFill>
-                <a:latin typeface="Calibri"/>
-              </a:defRPr>
-            </a:pPr>
-            <a:r>
-              <a:rPr dirty="0"/>
-              <a:t>Ireland + 18-25 age</a:t>
-            </a:r>
-          </a:p>
-        </p:txBody>
-      </p:sp>
-      <p:sp>
-        <p:nvSpPr>
-          <p:cNvPr id="6" name="TextBox 5"/>
-          <p:cNvSpPr txBox="1"/>
-          <p:nvPr/>
-        </p:nvSpPr>
-        <p:spPr>
-          <a:xfrm>
-            <a:off x="8229600" y="6492240"/>
-            <a:ext cx="731520" cy="274320"/>
+            <a:off x="1097280" y="1600200"/>
+            <a:ext cx="1554480" cy="731520"/>
           </a:xfrm>
           <a:prstGeom prst="rect">
             <a:avLst/>
@@ -8866,55 +9293,31 @@
           </a:bodyPr>
           <a:lstStyle/>
           <a:p>
-            <a:pPr algn="r">
-              <a:defRPr sz="1000">
-                <a:solidFill>
-                  <a:srgbClr val="7F8C8D"/>
-                </a:solidFill>
-                <a:latin typeface="Calibri"/>
-              </a:defRPr>
-            </a:pPr>
-            <a:r>
-              <a:t>8/10</a:t>
-            </a:r>
-          </a:p>
-        </p:txBody>
-      </p:sp>
-    </p:spTree>
-  </p:cSld>
-  <p:clrMapOvr>
-    <a:masterClrMapping/>
-  </p:clrMapOvr>
-</p:sld>
-</file>
-
-<file path=ppt/slides/slide9.xml><?xml version="1.0" encoding="utf-8"?>
-<p:sld xmlns:a="http://schemas.openxmlformats.org/drawingml/2006/main" xmlns:r="http://schemas.openxmlformats.org/officeDocument/2006/relationships" xmlns:p="http://schemas.openxmlformats.org/presentationml/2006/main">
-  <p:cSld>
-    <p:spTree>
-      <p:nvGrpSpPr>
-        <p:cNvPr id="1" name=""/>
-        <p:cNvGrpSpPr/>
-        <p:nvPr/>
-      </p:nvGrpSpPr>
-      <p:grpSpPr>
-        <a:xfrm>
-          <a:off x="0" y="0"/>
-          <a:ext cx="0" cy="0"/>
-          <a:chOff x="0" y="0"/>
-          <a:chExt cx="0" cy="0"/>
-        </a:xfrm>
-      </p:grpSpPr>
-      <p:sp>
-        <p:nvSpPr>
-          <p:cNvPr id="2" name="TextBox 1"/>
+            <a:pPr algn="ctr">
+              <a:defRPr sz="3600" b="1">
+                <a:solidFill>
+                  <a:srgbClr val="2ECC71"/>
+                </a:solidFill>
+                <a:latin typeface="Calibri"/>
+              </a:defRPr>
+            </a:pPr>
+            <a:r>
+              <a:rPr dirty="0"/>
+              <a:t>$10.86</a:t>
+            </a:r>
+          </a:p>
+        </p:txBody>
+      </p:sp>
+      <p:sp>
+        <p:nvSpPr>
+          <p:cNvPr id="5" name="TextBox 4"/>
           <p:cNvSpPr txBox="1"/>
           <p:nvPr/>
         </p:nvSpPr>
         <p:spPr>
           <a:xfrm>
-            <a:off x="457200" y="457200"/>
-            <a:ext cx="8229600" cy="914400"/>
+            <a:off x="1097280" y="2560320"/>
+            <a:ext cx="1554480" cy="365760"/>
           </a:xfrm>
           <a:prstGeom prst="rect">
             <a:avLst/>
@@ -8922,180 +9325,48 @@
           <a:noFill/>
         </p:spPr>
         <p:txBody>
-          <a:bodyPr wrap="square">
+          <a:bodyPr wrap="none">
             <a:spAutoFit/>
           </a:bodyPr>
           <a:lstStyle/>
           <a:p>
             <a:pPr algn="ctr">
-              <a:defRPr sz="3600" b="1">
-                <a:solidFill>
-                  <a:srgbClr val="2C3E50"/>
-                </a:solidFill>
-                <a:latin typeface="Calibri"/>
-              </a:defRPr>
-            </a:pPr>
-            <a:r>
-              <a:rPr dirty="0"/>
-              <a:t>Key Findings &amp; Recommendations</a:t>
-            </a:r>
-          </a:p>
-        </p:txBody>
-      </p:sp>
-      <p:sp>
-        <p:nvSpPr>
-          <p:cNvPr id="3" name="TextBox 2"/>
-          <p:cNvSpPr txBox="1"/>
-          <p:nvPr/>
-        </p:nvSpPr>
-        <p:spPr>
-          <a:xfrm>
-            <a:off x="1097280" y="2011680"/>
-            <a:ext cx="6949440" cy="3200400"/>
-          </a:xfrm>
-          <a:prstGeom prst="rect">
-            <a:avLst/>
-          </a:prstGeom>
-          <a:noFill/>
-        </p:spPr>
-        <p:txBody>
-          <a:bodyPr wrap="square">
-            <a:spAutoFit/>
-          </a:bodyPr>
-          <a:lstStyle/>
-          <a:p>
-            <a:pPr>
-              <a:spcBef>
-                <a:spcPts val="800"/>
-              </a:spcBef>
-              <a:spcAft>
-                <a:spcPts val="800"/>
-              </a:spcAft>
-              <a:defRPr sz="2000">
-                <a:solidFill>
-                  <a:srgbClr val="212121"/>
-                </a:solidFill>
-                <a:latin typeface="Calibri"/>
-              </a:defRPr>
-            </a:pPr>
-            <a:r>
-              <a:rPr dirty="0"/>
-              <a:t>65.6% retention → Protect core gameplay loop (3-4x industry avg)</a:t>
-            </a:r>
-          </a:p>
-          <a:p>
-            <a:pPr>
-              <a:spcBef>
-                <a:spcPts val="800"/>
-              </a:spcBef>
-              <a:spcAft>
-                <a:spcPts val="800"/>
-              </a:spcAft>
-              <a:defRPr sz="2000">
-                <a:solidFill>
-                  <a:srgbClr val="212121"/>
-                </a:solidFill>
-                <a:latin typeface="Calibri"/>
-              </a:defRPr>
-            </a:pPr>
-            <a:r>
-              <a:rPr dirty="0"/>
-              <a:t>51.5% conversion → Focus on ARPPU growth, not conversion</a:t>
-            </a:r>
-          </a:p>
-          <a:p>
-            <a:pPr>
-              <a:spcBef>
-                <a:spcPts val="800"/>
-              </a:spcBef>
-              <a:spcAft>
-                <a:spcPts val="800"/>
-              </a:spcAft>
-              <a:defRPr sz="2000">
-                <a:solidFill>
-                  <a:srgbClr val="212121"/>
-                </a:solidFill>
-                <a:latin typeface="Calibri"/>
-              </a:defRPr>
-            </a:pPr>
-            <a:r>
-              <a:rPr dirty="0"/>
-              <a:t>Diamond Pack dominance → Expand $50-$100 premium tier</a:t>
-            </a:r>
-          </a:p>
-          <a:p>
-            <a:pPr>
-              <a:spcBef>
-                <a:spcPts val="800"/>
-              </a:spcBef>
-              <a:spcAft>
-                <a:spcPts val="800"/>
-              </a:spcAft>
-              <a:defRPr sz="2000">
-                <a:solidFill>
-                  <a:srgbClr val="212121"/>
-                </a:solidFill>
-                <a:latin typeface="Calibri"/>
-              </a:defRPr>
-            </a:pPr>
-            <a:r>
-              <a:rPr dirty="0"/>
-              <a:t>Geographic winners → Target Ireland, Suriname, Brazil for UA</a:t>
-            </a:r>
-          </a:p>
-        </p:txBody>
-      </p:sp>
-      <p:sp>
-        <p:nvSpPr>
-          <p:cNvPr id="4" name="Rounded Rectangle 3"/>
+              <a:defRPr sz="1400">
+                <a:solidFill>
+                  <a:srgbClr val="7F8C8D"/>
+                </a:solidFill>
+                <a:latin typeface="Calibri"/>
+              </a:defRPr>
+            </a:pPr>
+            <a:r>
+              <a:t>ARPU</a:t>
+            </a:r>
+          </a:p>
+        </p:txBody>
+      </p:sp>
+      <p:sp>
+        <p:nvSpPr>
+          <p:cNvPr id="6" name="Rounded Rectangle 5"/>
           <p:cNvSpPr/>
           <p:nvPr/>
         </p:nvSpPr>
         <p:spPr>
           <a:xfrm>
-            <a:off x="1306285" y="5212080"/>
-            <a:ext cx="6531429" cy="914400"/>
+            <a:off x="2926080" y="1463040"/>
+            <a:ext cx="1554480" cy="1005840"/>
           </a:xfrm>
           <a:prstGeom prst="roundRect">
             <a:avLst/>
           </a:prstGeom>
-          <a:gradFill flip="none" rotWithShape="1">
-            <a:gsLst>
-              <a:gs pos="0">
-                <a:schemeClr val="accent4">
-                  <a:alpha val="40687"/>
-                  <a:lumMod val="73000"/>
-                </a:schemeClr>
-              </a:gs>
-              <a:gs pos="48000">
-                <a:schemeClr val="accent6">
-                  <a:lumMod val="97421"/>
-                  <a:lumOff val="2579"/>
-                  <a:alpha val="76000"/>
-                </a:schemeClr>
-              </a:gs>
-              <a:gs pos="100000">
-                <a:schemeClr val="accent4">
-                  <a:alpha val="67000"/>
-                  <a:lumMod val="90000"/>
-                </a:schemeClr>
-              </a:gs>
-            </a:gsLst>
-            <a:path path="circle">
-              <a:fillToRect l="100000" t="100000"/>
-            </a:path>
-            <a:tileRect r="-100000" b="-100000"/>
-          </a:gradFill>
+          <a:solidFill>
+            <a:srgbClr val="F8F9FA"/>
+          </a:solidFill>
           <a:ln w="6350">
-            <a:noFill/>
+            <a:solidFill>
+              <a:srgbClr val="ECF0F1"/>
+            </a:solidFill>
           </a:ln>
-          <a:effectLst>
-            <a:outerShdw blurRad="535990" sx="98000" sy="98000" algn="ctr" rotWithShape="0">
-              <a:prstClr val="black">
-                <a:alpha val="18347"/>
-              </a:prstClr>
-            </a:outerShdw>
-          </a:effectLst>
+          <a:effectLst/>
         </p:spPr>
         <p:style>
           <a:lnRef idx="1">
@@ -9122,14 +9393,459 @@
       </p:sp>
       <p:sp>
         <p:nvSpPr>
-          <p:cNvPr id="5" name="TextBox 4"/>
+          <p:cNvPr id="7" name="TextBox 6"/>
           <p:cNvSpPr txBox="1"/>
           <p:nvPr/>
         </p:nvSpPr>
         <p:spPr>
           <a:xfrm>
-            <a:off x="1306286" y="5303520"/>
-            <a:ext cx="6400800" cy="548640"/>
+            <a:off x="2926080" y="1600200"/>
+            <a:ext cx="1554480" cy="731520"/>
+          </a:xfrm>
+          <a:prstGeom prst="rect">
+            <a:avLst/>
+          </a:prstGeom>
+          <a:noFill/>
+        </p:spPr>
+        <p:txBody>
+          <a:bodyPr wrap="none">
+            <a:spAutoFit/>
+          </a:bodyPr>
+          <a:lstStyle/>
+          <a:p>
+            <a:pPr algn="ctr">
+              <a:defRPr sz="3600" b="1">
+                <a:solidFill>
+                  <a:srgbClr val="2ECC71"/>
+                </a:solidFill>
+                <a:latin typeface="Calibri"/>
+              </a:defRPr>
+            </a:pPr>
+            <a:r>
+              <a:rPr dirty="0"/>
+              <a:t>$21.07</a:t>
+            </a:r>
+          </a:p>
+        </p:txBody>
+      </p:sp>
+      <p:sp>
+        <p:nvSpPr>
+          <p:cNvPr id="8" name="TextBox 7"/>
+          <p:cNvSpPr txBox="1"/>
+          <p:nvPr/>
+        </p:nvSpPr>
+        <p:spPr>
+          <a:xfrm>
+            <a:off x="2926080" y="2560320"/>
+            <a:ext cx="1554480" cy="365760"/>
+          </a:xfrm>
+          <a:prstGeom prst="rect">
+            <a:avLst/>
+          </a:prstGeom>
+          <a:noFill/>
+        </p:spPr>
+        <p:txBody>
+          <a:bodyPr wrap="none">
+            <a:spAutoFit/>
+          </a:bodyPr>
+          <a:lstStyle/>
+          <a:p>
+            <a:pPr algn="ctr">
+              <a:defRPr sz="1400">
+                <a:solidFill>
+                  <a:srgbClr val="7F8C8D"/>
+                </a:solidFill>
+                <a:latin typeface="Calibri"/>
+              </a:defRPr>
+            </a:pPr>
+            <a:r>
+              <a:t>ARPPU</a:t>
+            </a:r>
+          </a:p>
+        </p:txBody>
+      </p:sp>
+      <p:sp>
+        <p:nvSpPr>
+          <p:cNvPr id="9" name="Rounded Rectangle 8"/>
+          <p:cNvSpPr/>
+          <p:nvPr/>
+        </p:nvSpPr>
+        <p:spPr>
+          <a:xfrm>
+            <a:off x="4754880" y="1463040"/>
+            <a:ext cx="1554480" cy="1005840"/>
+          </a:xfrm>
+          <a:prstGeom prst="roundRect">
+            <a:avLst/>
+          </a:prstGeom>
+          <a:solidFill>
+            <a:srgbClr val="F8F9FA"/>
+          </a:solidFill>
+          <a:ln w="6350">
+            <a:solidFill>
+              <a:srgbClr val="ECF0F1"/>
+            </a:solidFill>
+          </a:ln>
+          <a:effectLst/>
+        </p:spPr>
+        <p:style>
+          <a:lnRef idx="1">
+            <a:schemeClr val="accent1"/>
+          </a:lnRef>
+          <a:fillRef idx="3">
+            <a:schemeClr val="accent1"/>
+          </a:fillRef>
+          <a:effectRef idx="2">
+            <a:schemeClr val="accent1"/>
+          </a:effectRef>
+          <a:fontRef idx="minor">
+            <a:schemeClr val="lt1"/>
+          </a:fontRef>
+        </p:style>
+        <p:txBody>
+          <a:bodyPr rtlCol="0" anchor="ctr"/>
+          <a:lstStyle/>
+          <a:p>
+            <a:pPr algn="ctr"/>
+            <a:endParaRPr/>
+          </a:p>
+        </p:txBody>
+      </p:sp>
+      <p:sp>
+        <p:nvSpPr>
+          <p:cNvPr id="10" name="TextBox 9"/>
+          <p:cNvSpPr txBox="1"/>
+          <p:nvPr/>
+        </p:nvSpPr>
+        <p:spPr>
+          <a:xfrm>
+            <a:off x="4754880" y="1600200"/>
+            <a:ext cx="1554480" cy="731520"/>
+          </a:xfrm>
+          <a:prstGeom prst="rect">
+            <a:avLst/>
+          </a:prstGeom>
+          <a:noFill/>
+        </p:spPr>
+        <p:txBody>
+          <a:bodyPr wrap="none">
+            <a:spAutoFit/>
+          </a:bodyPr>
+          <a:lstStyle/>
+          <a:p>
+            <a:pPr algn="ctr">
+              <a:defRPr sz="3600" b="1">
+                <a:solidFill>
+                  <a:srgbClr val="2ECC71"/>
+                </a:solidFill>
+                <a:latin typeface="Calibri"/>
+              </a:defRPr>
+            </a:pPr>
+            <a:r>
+              <a:t>51.5%</a:t>
+            </a:r>
+          </a:p>
+        </p:txBody>
+      </p:sp>
+      <p:sp>
+        <p:nvSpPr>
+          <p:cNvPr id="11" name="TextBox 10"/>
+          <p:cNvSpPr txBox="1"/>
+          <p:nvPr/>
+        </p:nvSpPr>
+        <p:spPr>
+          <a:xfrm>
+            <a:off x="4754880" y="2560320"/>
+            <a:ext cx="1554480" cy="365760"/>
+          </a:xfrm>
+          <a:prstGeom prst="rect">
+            <a:avLst/>
+          </a:prstGeom>
+          <a:noFill/>
+        </p:spPr>
+        <p:txBody>
+          <a:bodyPr wrap="none">
+            <a:spAutoFit/>
+          </a:bodyPr>
+          <a:lstStyle/>
+          <a:p>
+            <a:pPr algn="ctr">
+              <a:defRPr sz="1400">
+                <a:solidFill>
+                  <a:srgbClr val="7F8C8D"/>
+                </a:solidFill>
+                <a:latin typeface="Calibri"/>
+              </a:defRPr>
+            </a:pPr>
+            <a:r>
+              <a:t>Conversion</a:t>
+            </a:r>
+          </a:p>
+        </p:txBody>
+      </p:sp>
+      <p:sp>
+        <p:nvSpPr>
+          <p:cNvPr id="12" name="Rounded Rectangle 11"/>
+          <p:cNvSpPr/>
+          <p:nvPr/>
+        </p:nvSpPr>
+        <p:spPr>
+          <a:xfrm>
+            <a:off x="6583680" y="1463040"/>
+            <a:ext cx="1554480" cy="1005840"/>
+          </a:xfrm>
+          <a:prstGeom prst="roundRect">
+            <a:avLst/>
+          </a:prstGeom>
+          <a:solidFill>
+            <a:srgbClr val="F8F9FA"/>
+          </a:solidFill>
+          <a:ln w="6350">
+            <a:solidFill>
+              <a:srgbClr val="ECF0F1"/>
+            </a:solidFill>
+          </a:ln>
+          <a:effectLst/>
+        </p:spPr>
+        <p:style>
+          <a:lnRef idx="1">
+            <a:schemeClr val="accent1"/>
+          </a:lnRef>
+          <a:fillRef idx="3">
+            <a:schemeClr val="accent1"/>
+          </a:fillRef>
+          <a:effectRef idx="2">
+            <a:schemeClr val="accent1"/>
+          </a:effectRef>
+          <a:fontRef idx="minor">
+            <a:schemeClr val="lt1"/>
+          </a:fontRef>
+        </p:style>
+        <p:txBody>
+          <a:bodyPr rtlCol="0" anchor="ctr"/>
+          <a:lstStyle/>
+          <a:p>
+            <a:pPr algn="ctr"/>
+            <a:endParaRPr/>
+          </a:p>
+        </p:txBody>
+      </p:sp>
+      <p:sp>
+        <p:nvSpPr>
+          <p:cNvPr id="13" name="TextBox 12"/>
+          <p:cNvSpPr txBox="1"/>
+          <p:nvPr/>
+        </p:nvSpPr>
+        <p:spPr>
+          <a:xfrm>
+            <a:off x="6583680" y="1600200"/>
+            <a:ext cx="1554480" cy="731520"/>
+          </a:xfrm>
+          <a:prstGeom prst="rect">
+            <a:avLst/>
+          </a:prstGeom>
+          <a:noFill/>
+        </p:spPr>
+        <p:txBody>
+          <a:bodyPr wrap="none">
+            <a:spAutoFit/>
+          </a:bodyPr>
+          <a:lstStyle/>
+          <a:p>
+            <a:pPr algn="ctr">
+              <a:defRPr sz="3600" b="1">
+                <a:solidFill>
+                  <a:srgbClr val="2ECC71"/>
+                </a:solidFill>
+                <a:latin typeface="Calibri"/>
+              </a:defRPr>
+            </a:pPr>
+            <a:r>
+              <a:t>$10.9K</a:t>
+            </a:r>
+          </a:p>
+        </p:txBody>
+      </p:sp>
+      <p:sp>
+        <p:nvSpPr>
+          <p:cNvPr id="14" name="TextBox 13"/>
+          <p:cNvSpPr txBox="1"/>
+          <p:nvPr/>
+        </p:nvSpPr>
+        <p:spPr>
+          <a:xfrm>
+            <a:off x="6583680" y="2560320"/>
+            <a:ext cx="1554480" cy="365760"/>
+          </a:xfrm>
+          <a:prstGeom prst="rect">
+            <a:avLst/>
+          </a:prstGeom>
+          <a:noFill/>
+        </p:spPr>
+        <p:txBody>
+          <a:bodyPr wrap="none">
+            <a:spAutoFit/>
+          </a:bodyPr>
+          <a:lstStyle/>
+          <a:p>
+            <a:pPr algn="ctr">
+              <a:defRPr sz="1400">
+                <a:solidFill>
+                  <a:srgbClr val="7F8C8D"/>
+                </a:solidFill>
+                <a:latin typeface="Calibri"/>
+              </a:defRPr>
+            </a:pPr>
+            <a:r>
+              <a:t>Total Revenue</a:t>
+            </a:r>
+          </a:p>
+        </p:txBody>
+      </p:sp>
+      <p:pic>
+        <p:nvPicPr>
+          <p:cNvPr id="15" name="Picture 14" descr="04_revenue_by_item.png"/>
+          <p:cNvPicPr>
+            <a:picLocks noChangeAspect="1"/>
+          </p:cNvPicPr>
+          <p:nvPr/>
+        </p:nvPicPr>
+        <p:blipFill>
+          <a:blip r:embed="rId2"/>
+          <a:stretch>
+            <a:fillRect/>
+          </a:stretch>
+        </p:blipFill>
+        <p:spPr>
+          <a:xfrm>
+            <a:off x="1737360" y="2926080"/>
+            <a:ext cx="5638800" cy="3383280"/>
+          </a:xfrm>
+          <a:prstGeom prst="rect">
+            <a:avLst/>
+          </a:prstGeom>
+        </p:spPr>
+      </p:pic>
+      <p:sp>
+        <p:nvSpPr>
+          <p:cNvPr id="16" name="TextBox 15"/>
+          <p:cNvSpPr txBox="1"/>
+          <p:nvPr/>
+        </p:nvSpPr>
+        <p:spPr>
+          <a:xfrm>
+            <a:off x="914400" y="6384175"/>
+            <a:ext cx="7315200" cy="457200"/>
+          </a:xfrm>
+          <a:prstGeom prst="rect">
+            <a:avLst/>
+          </a:prstGeom>
+          <a:noFill/>
+        </p:spPr>
+        <p:txBody>
+          <a:bodyPr wrap="square" anchor="t">
+            <a:spAutoFit/>
+          </a:bodyPr>
+          <a:lstStyle/>
+          <a:p>
+            <a:pPr algn="ctr">
+              <a:defRPr sz="1600" b="0">
+                <a:solidFill>
+                  <a:srgbClr val="7F8C8D"/>
+                </a:solidFill>
+                <a:latin typeface="Calibri"/>
+              </a:defRPr>
+            </a:pPr>
+            <a:r>
+              <a:rPr dirty="0"/>
+              <a:t>Diamond Pack ($49.99) drives 62% of revenue - premium monetization works</a:t>
+            </a:r>
+          </a:p>
+        </p:txBody>
+      </p:sp>
+      <p:sp>
+        <p:nvSpPr>
+          <p:cNvPr id="17" name="TextBox 16"/>
+          <p:cNvSpPr txBox="1"/>
+          <p:nvPr/>
+        </p:nvSpPr>
+        <p:spPr>
+          <a:xfrm>
+            <a:off x="8229600" y="6492240"/>
+            <a:ext cx="731520" cy="274320"/>
+          </a:xfrm>
+          <a:prstGeom prst="rect">
+            <a:avLst/>
+          </a:prstGeom>
+          <a:noFill/>
+        </p:spPr>
+        <p:txBody>
+          <a:bodyPr wrap="none">
+            <a:spAutoFit/>
+          </a:bodyPr>
+          <a:lstStyle/>
+          <a:p>
+            <a:pPr algn="r">
+              <a:defRPr sz="1000">
+                <a:solidFill>
+                  <a:srgbClr val="7F8C8D"/>
+                </a:solidFill>
+                <a:latin typeface="Calibri"/>
+              </a:defRPr>
+            </a:pPr>
+            <a:r>
+              <a:t>7/10</a:t>
+            </a:r>
+          </a:p>
+        </p:txBody>
+      </p:sp>
+    </p:spTree>
+  </p:cSld>
+  <p:clrMapOvr>
+    <a:masterClrMapping/>
+  </p:clrMapOvr>
+</p:sld>
+</file>
+
+<file path=ppt/slides/slide9.xml><?xml version="1.0" encoding="utf-8"?>
+<p:sld xmlns:a="http://schemas.openxmlformats.org/drawingml/2006/main" xmlns:r="http://schemas.openxmlformats.org/officeDocument/2006/relationships" xmlns:p="http://schemas.openxmlformats.org/presentationml/2006/main">
+  <p:cSld>
+    <p:spTree>
+      <p:nvGrpSpPr>
+        <p:cNvPr id="1" name="">
+          <a:extLst>
+            <a:ext uri="{FF2B5EF4-FFF2-40B4-BE49-F238E27FC236}">
+              <a16:creationId xmlns:a16="http://schemas.microsoft.com/office/drawing/2014/main" id="{37FDF630-D9DC-C226-E7C9-24F1BEC138C8}"/>
+            </a:ext>
+          </a:extLst>
+        </p:cNvPr>
+        <p:cNvGrpSpPr/>
+        <p:nvPr/>
+      </p:nvGrpSpPr>
+      <p:grpSpPr>
+        <a:xfrm>
+          <a:off x="0" y="0"/>
+          <a:ext cx="0" cy="0"/>
+          <a:chOff x="0" y="0"/>
+          <a:chExt cx="0" cy="0"/>
+        </a:xfrm>
+      </p:grpSpPr>
+      <p:sp>
+        <p:nvSpPr>
+          <p:cNvPr id="2" name="TextBox 1">
+            <a:extLst>
+              <a:ext uri="{FF2B5EF4-FFF2-40B4-BE49-F238E27FC236}">
+                <a16:creationId xmlns:a16="http://schemas.microsoft.com/office/drawing/2014/main" id="{ADD1D841-0DA7-F4BB-0C51-D656B980880B}"/>
+              </a:ext>
+            </a:extLst>
+          </p:cNvPr>
+          <p:cNvSpPr txBox="1"/>
+          <p:nvPr/>
+        </p:nvSpPr>
+        <p:spPr>
+          <a:xfrm>
+            <a:off x="457200" y="457200"/>
+            <a:ext cx="8229600" cy="914400"/>
           </a:xfrm>
           <a:prstGeom prst="rect">
             <a:avLst/>
@@ -9143,30 +9859,88 @@
           <a:lstStyle/>
           <a:p>
             <a:pPr algn="ctr">
-              <a:defRPr sz="2200" b="1">
-                <a:solidFill>
-                  <a:srgbClr val="FFFFFF"/>
-                </a:solidFill>
-                <a:latin typeface="Calibri"/>
-              </a:defRPr>
-            </a:pPr>
-            <a:r>
-              <a:rPr dirty="0"/>
-              <a:t>Action: Scale premium monetization for +31% revenue potential</a:t>
-            </a:r>
-          </a:p>
-        </p:txBody>
-      </p:sp>
-      <p:sp>
-        <p:nvSpPr>
-          <p:cNvPr id="6" name="TextBox 5"/>
+              <a:defRPr sz="4000" b="1">
+                <a:solidFill>
+                  <a:srgbClr val="2C3E50"/>
+                </a:solidFill>
+                <a:latin typeface="Calibri"/>
+              </a:defRPr>
+            </a:pPr>
+            <a:r>
+              <a:t>Monetization Success</a:t>
+            </a:r>
+          </a:p>
+        </p:txBody>
+      </p:sp>
+      <p:sp>
+        <p:nvSpPr>
+          <p:cNvPr id="3" name="Rounded Rectangle 2">
+            <a:extLst>
+              <a:ext uri="{FF2B5EF4-FFF2-40B4-BE49-F238E27FC236}">
+                <a16:creationId xmlns:a16="http://schemas.microsoft.com/office/drawing/2014/main" id="{FEA3B95A-5E71-711E-E3D3-4CBEB5921D2E}"/>
+              </a:ext>
+            </a:extLst>
+          </p:cNvPr>
+          <p:cNvSpPr/>
+          <p:nvPr/>
+        </p:nvSpPr>
+        <p:spPr>
+          <a:xfrm>
+            <a:off x="1097280" y="1463040"/>
+            <a:ext cx="1554480" cy="1005840"/>
+          </a:xfrm>
+          <a:prstGeom prst="roundRect">
+            <a:avLst/>
+          </a:prstGeom>
+          <a:solidFill>
+            <a:srgbClr val="F8F9FA"/>
+          </a:solidFill>
+          <a:ln w="6350">
+            <a:solidFill>
+              <a:srgbClr val="ECF0F1"/>
+            </a:solidFill>
+          </a:ln>
+          <a:effectLst/>
+        </p:spPr>
+        <p:style>
+          <a:lnRef idx="1">
+            <a:schemeClr val="accent1"/>
+          </a:lnRef>
+          <a:fillRef idx="3">
+            <a:schemeClr val="accent1"/>
+          </a:fillRef>
+          <a:effectRef idx="2">
+            <a:schemeClr val="accent1"/>
+          </a:effectRef>
+          <a:fontRef idx="minor">
+            <a:schemeClr val="lt1"/>
+          </a:fontRef>
+        </p:style>
+        <p:txBody>
+          <a:bodyPr rtlCol="0" anchor="ctr"/>
+          <a:lstStyle/>
+          <a:p>
+            <a:pPr algn="ctr"/>
+            <a:endParaRPr/>
+          </a:p>
+        </p:txBody>
+      </p:sp>
+      <p:sp>
+        <p:nvSpPr>
+          <p:cNvPr id="4" name="TextBox 3">
+            <a:extLst>
+              <a:ext uri="{FF2B5EF4-FFF2-40B4-BE49-F238E27FC236}">
+                <a16:creationId xmlns:a16="http://schemas.microsoft.com/office/drawing/2014/main" id="{EC4DA6D8-7CFD-F0C5-B42A-60653E20EB74}"/>
+              </a:ext>
+            </a:extLst>
+          </p:cNvPr>
           <p:cNvSpPr txBox="1"/>
           <p:nvPr/>
         </p:nvSpPr>
         <p:spPr>
           <a:xfrm>
-            <a:off x="8229600" y="6492240"/>
-            <a:ext cx="731520" cy="274320"/>
+            <a:off x="1097280" y="1600200"/>
+            <a:ext cx="1554480" cy="731520"/>
           </a:xfrm>
           <a:prstGeom prst="rect">
             <a:avLst/>
@@ -9179,6 +9953,547 @@
           </a:bodyPr>
           <a:lstStyle/>
           <a:p>
+            <a:pPr algn="ctr">
+              <a:defRPr sz="3600" b="1">
+                <a:solidFill>
+                  <a:srgbClr val="2ECC71"/>
+                </a:solidFill>
+                <a:latin typeface="Calibri"/>
+              </a:defRPr>
+            </a:pPr>
+            <a:r>
+              <a:rPr dirty="0"/>
+              <a:t>$10.86</a:t>
+            </a:r>
+          </a:p>
+        </p:txBody>
+      </p:sp>
+      <p:sp>
+        <p:nvSpPr>
+          <p:cNvPr id="5" name="TextBox 4">
+            <a:extLst>
+              <a:ext uri="{FF2B5EF4-FFF2-40B4-BE49-F238E27FC236}">
+                <a16:creationId xmlns:a16="http://schemas.microsoft.com/office/drawing/2014/main" id="{16BD42A1-CDC7-87E7-D456-D0C24AC35C78}"/>
+              </a:ext>
+            </a:extLst>
+          </p:cNvPr>
+          <p:cNvSpPr txBox="1"/>
+          <p:nvPr/>
+        </p:nvSpPr>
+        <p:spPr>
+          <a:xfrm>
+            <a:off x="1097280" y="2560320"/>
+            <a:ext cx="1554480" cy="365760"/>
+          </a:xfrm>
+          <a:prstGeom prst="rect">
+            <a:avLst/>
+          </a:prstGeom>
+          <a:noFill/>
+        </p:spPr>
+        <p:txBody>
+          <a:bodyPr wrap="none">
+            <a:spAutoFit/>
+          </a:bodyPr>
+          <a:lstStyle/>
+          <a:p>
+            <a:pPr algn="ctr">
+              <a:defRPr sz="1400">
+                <a:solidFill>
+                  <a:srgbClr val="7F8C8D"/>
+                </a:solidFill>
+                <a:latin typeface="Calibri"/>
+              </a:defRPr>
+            </a:pPr>
+            <a:r>
+              <a:t>ARPU</a:t>
+            </a:r>
+          </a:p>
+        </p:txBody>
+      </p:sp>
+      <p:sp>
+        <p:nvSpPr>
+          <p:cNvPr id="6" name="Rounded Rectangle 5">
+            <a:extLst>
+              <a:ext uri="{FF2B5EF4-FFF2-40B4-BE49-F238E27FC236}">
+                <a16:creationId xmlns:a16="http://schemas.microsoft.com/office/drawing/2014/main" id="{F8DF3CD4-5CC2-CE51-B5FD-D85381241F25}"/>
+              </a:ext>
+            </a:extLst>
+          </p:cNvPr>
+          <p:cNvSpPr/>
+          <p:nvPr/>
+        </p:nvSpPr>
+        <p:spPr>
+          <a:xfrm>
+            <a:off x="2926080" y="1463040"/>
+            <a:ext cx="1554480" cy="1005840"/>
+          </a:xfrm>
+          <a:prstGeom prst="roundRect">
+            <a:avLst/>
+          </a:prstGeom>
+          <a:solidFill>
+            <a:srgbClr val="F8F9FA"/>
+          </a:solidFill>
+          <a:ln w="6350">
+            <a:solidFill>
+              <a:srgbClr val="ECF0F1"/>
+            </a:solidFill>
+          </a:ln>
+          <a:effectLst/>
+        </p:spPr>
+        <p:style>
+          <a:lnRef idx="1">
+            <a:schemeClr val="accent1"/>
+          </a:lnRef>
+          <a:fillRef idx="3">
+            <a:schemeClr val="accent1"/>
+          </a:fillRef>
+          <a:effectRef idx="2">
+            <a:schemeClr val="accent1"/>
+          </a:effectRef>
+          <a:fontRef idx="minor">
+            <a:schemeClr val="lt1"/>
+          </a:fontRef>
+        </p:style>
+        <p:txBody>
+          <a:bodyPr rtlCol="0" anchor="ctr"/>
+          <a:lstStyle/>
+          <a:p>
+            <a:pPr algn="ctr"/>
+            <a:endParaRPr/>
+          </a:p>
+        </p:txBody>
+      </p:sp>
+      <p:sp>
+        <p:nvSpPr>
+          <p:cNvPr id="7" name="TextBox 6">
+            <a:extLst>
+              <a:ext uri="{FF2B5EF4-FFF2-40B4-BE49-F238E27FC236}">
+                <a16:creationId xmlns:a16="http://schemas.microsoft.com/office/drawing/2014/main" id="{7ED605B2-0EDF-B9D6-41BD-F87ABA498388}"/>
+              </a:ext>
+            </a:extLst>
+          </p:cNvPr>
+          <p:cNvSpPr txBox="1"/>
+          <p:nvPr/>
+        </p:nvSpPr>
+        <p:spPr>
+          <a:xfrm>
+            <a:off x="2926080" y="1600200"/>
+            <a:ext cx="1554480" cy="731520"/>
+          </a:xfrm>
+          <a:prstGeom prst="rect">
+            <a:avLst/>
+          </a:prstGeom>
+          <a:noFill/>
+        </p:spPr>
+        <p:txBody>
+          <a:bodyPr wrap="none">
+            <a:spAutoFit/>
+          </a:bodyPr>
+          <a:lstStyle/>
+          <a:p>
+            <a:pPr algn="ctr">
+              <a:defRPr sz="3600" b="1">
+                <a:solidFill>
+                  <a:srgbClr val="2ECC71"/>
+                </a:solidFill>
+                <a:latin typeface="Calibri"/>
+              </a:defRPr>
+            </a:pPr>
+            <a:r>
+              <a:rPr dirty="0"/>
+              <a:t>$21.07</a:t>
+            </a:r>
+          </a:p>
+        </p:txBody>
+      </p:sp>
+      <p:sp>
+        <p:nvSpPr>
+          <p:cNvPr id="8" name="TextBox 7">
+            <a:extLst>
+              <a:ext uri="{FF2B5EF4-FFF2-40B4-BE49-F238E27FC236}">
+                <a16:creationId xmlns:a16="http://schemas.microsoft.com/office/drawing/2014/main" id="{25B7C85F-B87C-9883-B2BB-084544A88567}"/>
+              </a:ext>
+            </a:extLst>
+          </p:cNvPr>
+          <p:cNvSpPr txBox="1"/>
+          <p:nvPr/>
+        </p:nvSpPr>
+        <p:spPr>
+          <a:xfrm>
+            <a:off x="2926080" y="2560320"/>
+            <a:ext cx="1554480" cy="365760"/>
+          </a:xfrm>
+          <a:prstGeom prst="rect">
+            <a:avLst/>
+          </a:prstGeom>
+          <a:noFill/>
+        </p:spPr>
+        <p:txBody>
+          <a:bodyPr wrap="none">
+            <a:spAutoFit/>
+          </a:bodyPr>
+          <a:lstStyle/>
+          <a:p>
+            <a:pPr algn="ctr">
+              <a:defRPr sz="1400">
+                <a:solidFill>
+                  <a:srgbClr val="7F8C8D"/>
+                </a:solidFill>
+                <a:latin typeface="Calibri"/>
+              </a:defRPr>
+            </a:pPr>
+            <a:r>
+              <a:t>ARPPU</a:t>
+            </a:r>
+          </a:p>
+        </p:txBody>
+      </p:sp>
+      <p:sp>
+        <p:nvSpPr>
+          <p:cNvPr id="9" name="Rounded Rectangle 8">
+            <a:extLst>
+              <a:ext uri="{FF2B5EF4-FFF2-40B4-BE49-F238E27FC236}">
+                <a16:creationId xmlns:a16="http://schemas.microsoft.com/office/drawing/2014/main" id="{67C48A71-2C03-9770-999D-726F6C80D26A}"/>
+              </a:ext>
+            </a:extLst>
+          </p:cNvPr>
+          <p:cNvSpPr/>
+          <p:nvPr/>
+        </p:nvSpPr>
+        <p:spPr>
+          <a:xfrm>
+            <a:off x="4754880" y="1463040"/>
+            <a:ext cx="1554480" cy="1005840"/>
+          </a:xfrm>
+          <a:prstGeom prst="roundRect">
+            <a:avLst/>
+          </a:prstGeom>
+          <a:solidFill>
+            <a:srgbClr val="F8F9FA"/>
+          </a:solidFill>
+          <a:ln w="6350">
+            <a:solidFill>
+              <a:srgbClr val="ECF0F1"/>
+            </a:solidFill>
+          </a:ln>
+          <a:effectLst/>
+        </p:spPr>
+        <p:style>
+          <a:lnRef idx="1">
+            <a:schemeClr val="accent1"/>
+          </a:lnRef>
+          <a:fillRef idx="3">
+            <a:schemeClr val="accent1"/>
+          </a:fillRef>
+          <a:effectRef idx="2">
+            <a:schemeClr val="accent1"/>
+          </a:effectRef>
+          <a:fontRef idx="minor">
+            <a:schemeClr val="lt1"/>
+          </a:fontRef>
+        </p:style>
+        <p:txBody>
+          <a:bodyPr rtlCol="0" anchor="ctr"/>
+          <a:lstStyle/>
+          <a:p>
+            <a:pPr algn="ctr"/>
+            <a:endParaRPr/>
+          </a:p>
+        </p:txBody>
+      </p:sp>
+      <p:sp>
+        <p:nvSpPr>
+          <p:cNvPr id="10" name="TextBox 9">
+            <a:extLst>
+              <a:ext uri="{FF2B5EF4-FFF2-40B4-BE49-F238E27FC236}">
+                <a16:creationId xmlns:a16="http://schemas.microsoft.com/office/drawing/2014/main" id="{D54BF583-FA31-B847-3C24-8B56D8E8532F}"/>
+              </a:ext>
+            </a:extLst>
+          </p:cNvPr>
+          <p:cNvSpPr txBox="1"/>
+          <p:nvPr/>
+        </p:nvSpPr>
+        <p:spPr>
+          <a:xfrm>
+            <a:off x="4754880" y="1600200"/>
+            <a:ext cx="1554480" cy="731520"/>
+          </a:xfrm>
+          <a:prstGeom prst="rect">
+            <a:avLst/>
+          </a:prstGeom>
+          <a:noFill/>
+        </p:spPr>
+        <p:txBody>
+          <a:bodyPr wrap="none">
+            <a:spAutoFit/>
+          </a:bodyPr>
+          <a:lstStyle/>
+          <a:p>
+            <a:pPr algn="ctr">
+              <a:defRPr sz="3600" b="1">
+                <a:solidFill>
+                  <a:srgbClr val="2ECC71"/>
+                </a:solidFill>
+                <a:latin typeface="Calibri"/>
+              </a:defRPr>
+            </a:pPr>
+            <a:r>
+              <a:t>51.5%</a:t>
+            </a:r>
+          </a:p>
+        </p:txBody>
+      </p:sp>
+      <p:sp>
+        <p:nvSpPr>
+          <p:cNvPr id="11" name="TextBox 10">
+            <a:extLst>
+              <a:ext uri="{FF2B5EF4-FFF2-40B4-BE49-F238E27FC236}">
+                <a16:creationId xmlns:a16="http://schemas.microsoft.com/office/drawing/2014/main" id="{21EF9B9D-E0F9-FF22-1726-065E10821F56}"/>
+              </a:ext>
+            </a:extLst>
+          </p:cNvPr>
+          <p:cNvSpPr txBox="1"/>
+          <p:nvPr/>
+        </p:nvSpPr>
+        <p:spPr>
+          <a:xfrm>
+            <a:off x="4754880" y="2560320"/>
+            <a:ext cx="1554480" cy="365760"/>
+          </a:xfrm>
+          <a:prstGeom prst="rect">
+            <a:avLst/>
+          </a:prstGeom>
+          <a:noFill/>
+        </p:spPr>
+        <p:txBody>
+          <a:bodyPr wrap="none">
+            <a:spAutoFit/>
+          </a:bodyPr>
+          <a:lstStyle/>
+          <a:p>
+            <a:pPr algn="ctr">
+              <a:defRPr sz="1400">
+                <a:solidFill>
+                  <a:srgbClr val="7F8C8D"/>
+                </a:solidFill>
+                <a:latin typeface="Calibri"/>
+              </a:defRPr>
+            </a:pPr>
+            <a:r>
+              <a:t>Conversion</a:t>
+            </a:r>
+          </a:p>
+        </p:txBody>
+      </p:sp>
+      <p:sp>
+        <p:nvSpPr>
+          <p:cNvPr id="12" name="Rounded Rectangle 11">
+            <a:extLst>
+              <a:ext uri="{FF2B5EF4-FFF2-40B4-BE49-F238E27FC236}">
+                <a16:creationId xmlns:a16="http://schemas.microsoft.com/office/drawing/2014/main" id="{C6DDCF53-A631-8911-3D9D-F960047EB431}"/>
+              </a:ext>
+            </a:extLst>
+          </p:cNvPr>
+          <p:cNvSpPr/>
+          <p:nvPr/>
+        </p:nvSpPr>
+        <p:spPr>
+          <a:xfrm>
+            <a:off x="6583680" y="1463040"/>
+            <a:ext cx="1554480" cy="1005840"/>
+          </a:xfrm>
+          <a:prstGeom prst="roundRect">
+            <a:avLst/>
+          </a:prstGeom>
+          <a:solidFill>
+            <a:srgbClr val="F8F9FA"/>
+          </a:solidFill>
+          <a:ln w="6350">
+            <a:solidFill>
+              <a:srgbClr val="ECF0F1"/>
+            </a:solidFill>
+          </a:ln>
+          <a:effectLst/>
+        </p:spPr>
+        <p:style>
+          <a:lnRef idx="1">
+            <a:schemeClr val="accent1"/>
+          </a:lnRef>
+          <a:fillRef idx="3">
+            <a:schemeClr val="accent1"/>
+          </a:fillRef>
+          <a:effectRef idx="2">
+            <a:schemeClr val="accent1"/>
+          </a:effectRef>
+          <a:fontRef idx="minor">
+            <a:schemeClr val="lt1"/>
+          </a:fontRef>
+        </p:style>
+        <p:txBody>
+          <a:bodyPr rtlCol="0" anchor="ctr"/>
+          <a:lstStyle/>
+          <a:p>
+            <a:pPr algn="ctr"/>
+            <a:endParaRPr/>
+          </a:p>
+        </p:txBody>
+      </p:sp>
+      <p:sp>
+        <p:nvSpPr>
+          <p:cNvPr id="13" name="TextBox 12">
+            <a:extLst>
+              <a:ext uri="{FF2B5EF4-FFF2-40B4-BE49-F238E27FC236}">
+                <a16:creationId xmlns:a16="http://schemas.microsoft.com/office/drawing/2014/main" id="{3C129C02-26B8-9E66-625E-04C4CEF2A40E}"/>
+              </a:ext>
+            </a:extLst>
+          </p:cNvPr>
+          <p:cNvSpPr txBox="1"/>
+          <p:nvPr/>
+        </p:nvSpPr>
+        <p:spPr>
+          <a:xfrm>
+            <a:off x="6583680" y="1600200"/>
+            <a:ext cx="1554480" cy="731520"/>
+          </a:xfrm>
+          <a:prstGeom prst="rect">
+            <a:avLst/>
+          </a:prstGeom>
+          <a:noFill/>
+        </p:spPr>
+        <p:txBody>
+          <a:bodyPr wrap="none">
+            <a:spAutoFit/>
+          </a:bodyPr>
+          <a:lstStyle/>
+          <a:p>
+            <a:pPr algn="ctr">
+              <a:defRPr sz="3600" b="1">
+                <a:solidFill>
+                  <a:srgbClr val="2ECC71"/>
+                </a:solidFill>
+                <a:latin typeface="Calibri"/>
+              </a:defRPr>
+            </a:pPr>
+            <a:r>
+              <a:t>$10.9K</a:t>
+            </a:r>
+          </a:p>
+        </p:txBody>
+      </p:sp>
+      <p:sp>
+        <p:nvSpPr>
+          <p:cNvPr id="14" name="TextBox 13">
+            <a:extLst>
+              <a:ext uri="{FF2B5EF4-FFF2-40B4-BE49-F238E27FC236}">
+                <a16:creationId xmlns:a16="http://schemas.microsoft.com/office/drawing/2014/main" id="{188923A1-5C3A-5084-8688-9D985540F3F2}"/>
+              </a:ext>
+            </a:extLst>
+          </p:cNvPr>
+          <p:cNvSpPr txBox="1"/>
+          <p:nvPr/>
+        </p:nvSpPr>
+        <p:spPr>
+          <a:xfrm>
+            <a:off x="6583680" y="2560320"/>
+            <a:ext cx="1554480" cy="365760"/>
+          </a:xfrm>
+          <a:prstGeom prst="rect">
+            <a:avLst/>
+          </a:prstGeom>
+          <a:noFill/>
+        </p:spPr>
+        <p:txBody>
+          <a:bodyPr wrap="none">
+            <a:spAutoFit/>
+          </a:bodyPr>
+          <a:lstStyle/>
+          <a:p>
+            <a:pPr algn="ctr">
+              <a:defRPr sz="1400">
+                <a:solidFill>
+                  <a:srgbClr val="7F8C8D"/>
+                </a:solidFill>
+                <a:latin typeface="Calibri"/>
+              </a:defRPr>
+            </a:pPr>
+            <a:r>
+              <a:t>Total Revenue</a:t>
+            </a:r>
+          </a:p>
+        </p:txBody>
+      </p:sp>
+      <p:sp>
+        <p:nvSpPr>
+          <p:cNvPr id="16" name="TextBox 15">
+            <a:extLst>
+              <a:ext uri="{FF2B5EF4-FFF2-40B4-BE49-F238E27FC236}">
+                <a16:creationId xmlns:a16="http://schemas.microsoft.com/office/drawing/2014/main" id="{5A8C2941-5FD6-3421-7D57-B676F93DFDA5}"/>
+              </a:ext>
+            </a:extLst>
+          </p:cNvPr>
+          <p:cNvSpPr txBox="1"/>
+          <p:nvPr/>
+        </p:nvSpPr>
+        <p:spPr>
+          <a:xfrm>
+            <a:off x="914400" y="6384175"/>
+            <a:ext cx="7315200" cy="338554"/>
+          </a:xfrm>
+          <a:prstGeom prst="rect">
+            <a:avLst/>
+          </a:prstGeom>
+          <a:noFill/>
+        </p:spPr>
+        <p:txBody>
+          <a:bodyPr wrap="square" anchor="t">
+            <a:spAutoFit/>
+          </a:bodyPr>
+          <a:lstStyle/>
+          <a:p>
+            <a:pPr algn="ctr">
+              <a:defRPr sz="1600" b="0">
+                <a:solidFill>
+                  <a:srgbClr val="7F8C8D"/>
+                </a:solidFill>
+                <a:latin typeface="Calibri"/>
+              </a:defRPr>
+            </a:pPr>
+            <a:r>
+              <a:rPr lang="en-US" dirty="0"/>
+              <a:t>Further Clue Aggregated by Country and Age Group</a:t>
+            </a:r>
+            <a:endParaRPr dirty="0"/>
+          </a:p>
+        </p:txBody>
+      </p:sp>
+      <p:sp>
+        <p:nvSpPr>
+          <p:cNvPr id="17" name="TextBox 16">
+            <a:extLst>
+              <a:ext uri="{FF2B5EF4-FFF2-40B4-BE49-F238E27FC236}">
+                <a16:creationId xmlns:a16="http://schemas.microsoft.com/office/drawing/2014/main" id="{29C2F0EA-2AA2-D509-6F51-6161518CEC14}"/>
+              </a:ext>
+            </a:extLst>
+          </p:cNvPr>
+          <p:cNvSpPr txBox="1"/>
+          <p:nvPr/>
+        </p:nvSpPr>
+        <p:spPr>
+          <a:xfrm>
+            <a:off x="8229600" y="6492240"/>
+            <a:ext cx="731520" cy="274320"/>
+          </a:xfrm>
+          <a:prstGeom prst="rect">
+            <a:avLst/>
+          </a:prstGeom>
+          <a:noFill/>
+        </p:spPr>
+        <p:txBody>
+          <a:bodyPr wrap="none">
+            <a:spAutoFit/>
+          </a:bodyPr>
+          <a:lstStyle/>
+          <a:p>
             <a:pPr algn="r">
               <a:defRPr sz="1000">
                 <a:solidFill>
@@ -9188,12 +10503,77 @@
               </a:defRPr>
             </a:pPr>
             <a:r>
-              <a:t>9/10</a:t>
-            </a:r>
-          </a:p>
-        </p:txBody>
-      </p:sp>
+              <a:t>7/10</a:t>
+            </a:r>
+          </a:p>
+        </p:txBody>
+      </p:sp>
+      <p:pic>
+        <p:nvPicPr>
+          <p:cNvPr id="19" name="Picture 18" descr="A graph with orange bars&#10;&#10;AI-generated content may be incorrect.">
+            <a:extLst>
+              <a:ext uri="{FF2B5EF4-FFF2-40B4-BE49-F238E27FC236}">
+                <a16:creationId xmlns:a16="http://schemas.microsoft.com/office/drawing/2014/main" id="{D4D41CD6-228C-A320-93D1-A1EAE9346968}"/>
+              </a:ext>
+            </a:extLst>
+          </p:cNvPr>
+          <p:cNvPicPr>
+            <a:picLocks noChangeAspect="1"/>
+          </p:cNvPicPr>
+          <p:nvPr/>
+        </p:nvPicPr>
+        <p:blipFill>
+          <a:blip r:embed="rId2"/>
+          <a:stretch>
+            <a:fillRect/>
+          </a:stretch>
+        </p:blipFill>
+        <p:spPr>
+          <a:xfrm>
+            <a:off x="137160" y="3324675"/>
+            <a:ext cx="4434840" cy="2660904"/>
+          </a:xfrm>
+          <a:prstGeom prst="rect">
+            <a:avLst/>
+          </a:prstGeom>
+        </p:spPr>
+      </p:pic>
+      <p:pic>
+        <p:nvPicPr>
+          <p:cNvPr id="21" name="Picture 20" descr="A graph of a group&#10;&#10;AI-generated content may be incorrect.">
+            <a:extLst>
+              <a:ext uri="{FF2B5EF4-FFF2-40B4-BE49-F238E27FC236}">
+                <a16:creationId xmlns:a16="http://schemas.microsoft.com/office/drawing/2014/main" id="{B0382C1D-D6EA-7F2F-B82E-EF198EF70D1D}"/>
+              </a:ext>
+            </a:extLst>
+          </p:cNvPr>
+          <p:cNvPicPr>
+            <a:picLocks noChangeAspect="1"/>
+          </p:cNvPicPr>
+          <p:nvPr/>
+        </p:nvPicPr>
+        <p:blipFill>
+          <a:blip r:embed="rId3"/>
+          <a:stretch>
+            <a:fillRect/>
+          </a:stretch>
+        </p:blipFill>
+        <p:spPr>
+          <a:xfrm>
+            <a:off x="4572000" y="3324675"/>
+            <a:ext cx="4520538" cy="2712323"/>
+          </a:xfrm>
+          <a:prstGeom prst="rect">
+            <a:avLst/>
+          </a:prstGeom>
+        </p:spPr>
+      </p:pic>
     </p:spTree>
+    <p:extLst>
+      <p:ext uri="{BB962C8B-B14F-4D97-AF65-F5344CB8AC3E}">
+        <p14:creationId xmlns:p14="http://schemas.microsoft.com/office/powerpoint/2010/main" val="1814450025"/>
+      </p:ext>
+    </p:extLst>
   </p:cSld>
   <p:clrMapOvr>
     <a:masterClrMapping/>

</xml_diff>